<commit_message>
M13: Sim-Review umgesetzt (sim_review true, Inhalt aktualisiert)
Co-Authored-By: Claude Opus 4.8 <noreply@anthropic.com>
</commit_message>
<xml_diff>
--- a/protected-downloads/praesentation/M13.pptx
+++ b/protected-downloads/praesentation/M13.pptx
@@ -9464,7 +9464,7 @@
                 </a:solidFill>
                 <a:latin typeface="Arial"/>
               </a:rPr>
-              <a:t>▸  Die relevanten Verbundpartner den typischen Bedarfsfeldern der Firmenkunden zuordnen</a:t>
+              <a:t>▸  Die Verbundpartner-Matrix anwenden und einem Kundenprofil den passenden Verbundpartner zuordnen sowie den nächsten Gesprächsschritt ableiten</a:t>
             </a:r>
           </a:p>
           <a:p>
@@ -9483,7 +9483,7 @@
                 </a:solidFill>
                 <a:latin typeface="Arial"/>
               </a:rPr>
-              <a:t>▸  Produktgetriebenes Push-Cross-Selling von bedarfsorientiertem Cross-Selling unterscheiden und die situationsgerechte Vorgehensweise wählen</a:t>
+              <a:t>▸  Den Unterschied zwischen Push- und Pull-Cross-Selling beschreiben und erläutern, warum der bedarfsorientierte Ansatz für Kundenbindung und Ertrag wirksamer ist</a:t>
             </a:r>
           </a:p>
         </p:txBody>
@@ -9875,7 +9875,7 @@
                 </a:solidFill>
                 <a:latin typeface="Arial"/>
               </a:rPr>
-              <a:t>  ·  Kurzinput + Flipchart</a:t>
+              <a:t>  ·  Kurzinput + Flipchart + agree-Live-Demo (3 Min)</a:t>
             </a:r>
           </a:p>
           <a:p>
@@ -9968,7 +9968,7 @@
                 </a:solidFill>
                 <a:latin typeface="Consolas"/>
               </a:rPr>
-              <a:t>50–75 min   </a:t>
+              <a:t>50–80 min   </a:t>
             </a:r>
             <a:r>
               <a:rPr sz="1500" b="1">
@@ -10005,7 +10005,7 @@
                 </a:solidFill>
                 <a:latin typeface="Consolas"/>
               </a:rPr>
-              <a:t>75–85 min   </a:t>
+              <a:t>80–90 min   </a:t>
             </a:r>
             <a:r>
               <a:rPr sz="1500" b="1">
@@ -10042,7 +10042,7 @@
                 </a:solidFill>
                 <a:latin typeface="Consolas"/>
               </a:rPr>
-              <a:t>85–90 min   </a:t>
+              <a:t>90–95 min   </a:t>
             </a:r>
             <a:r>
               <a:rPr sz="1500" b="1">

</xml_diff>

<commit_message>
M-Track Batch 2: M13 Deck (Web/Workbook)
Co-Authored-By: Claude Fable 5 <noreply@anthropic.com>
</commit_message>
<xml_diff>
--- a/protected-downloads/praesentation/M13.pptx
+++ b/protected-downloads/praesentation/M13.pptx
@@ -20,8 +20,6 @@
     <p:sldId id="268" r:id="rId20"/>
     <p:sldId id="269" r:id="rId21"/>
     <p:sldId id="270" r:id="rId22"/>
-    <p:sldId id="271" r:id="rId23"/>
-    <p:sldId id="272" r:id="rId24"/>
   </p:sldIdLst>
   <p:sldSz cx="12188952" cy="6858000" type="screen4x3"/>
   <p:notesSz cx="6858000" cy="9144000"/>
@@ -543,146 +541,6 @@
 </p:notes>
 </file>
 
-<file path=ppt/notesSlides/notesSlide10.xml><?xml version="1.0" encoding="utf-8"?>
-<p:notes xmlns:a="http://schemas.openxmlformats.org/drawingml/2006/main" xmlns:p="http://schemas.openxmlformats.org/presentationml/2006/main" xmlns:r="http://schemas.openxmlformats.org/officeDocument/2006/relationships">
-  <p:cSld>
-    <p:spTree>
-      <p:nvGrpSpPr>
-        <p:cNvPr id="1" name=""/>
-        <p:cNvGrpSpPr/>
-        <p:nvPr/>
-      </p:nvGrpSpPr>
-      <p:grpSpPr>
-        <a:xfrm>
-          <a:off x="0" y="0"/>
-          <a:ext cx="0" cy="0"/>
-          <a:chOff x="0" y="0"/>
-          <a:chExt cx="0" cy="0"/>
-        </a:xfrm>
-      </p:grpSpPr>
-      <p:sp>
-        <p:nvSpPr>
-          <p:cNvPr id="2" name="Slide Image Placeholder 1"/>
-          <p:cNvSpPr>
-            <a:spLocks noGrp="1"/>
-          </p:cNvSpPr>
-          <p:nvPr>
-            <p:ph type="sldImg" idx="2"/>
-          </p:nvPr>
-        </p:nvSpPr>
-        <p:spPr/>
-      </p:sp>
-      <p:sp>
-        <p:nvSpPr>
-          <p:cNvPr id="3" name="Notes Placeholder 2"/>
-          <p:cNvSpPr>
-            <a:spLocks noGrp="1"/>
-          </p:cNvSpPr>
-          <p:nvPr>
-            <p:ph type="body" idx="3" sz="quarter"/>
-          </p:nvPr>
-        </p:nvSpPr>
-        <p:spPr/>
-        <p:txBody>
-          <a:bodyPr/>
-          <a:lstStyle/>
-          <a:p>
-            <a:r>
-              <a:t>Siehe Trainerhandbuch (Sektion 3) für Moderationshinweise, Timing und erwartete Teilnehmerreaktionen.</a:t>
-            </a:r>
-          </a:p>
-        </p:txBody>
-      </p:sp>
-      <p:sp>
-        <p:nvSpPr>
-          <p:cNvPr id="4" name="Slide Number Placeholder 3"/>
-          <p:cNvSpPr>
-            <a:spLocks noGrp="1"/>
-          </p:cNvSpPr>
-          <p:nvPr>
-            <p:ph type="sldNum" idx="5" sz="quarter"/>
-          </p:nvPr>
-        </p:nvSpPr>
-        <p:spPr/>
-      </p:sp>
-    </p:spTree>
-  </p:cSld>
-  <p:clrMapOvr>
-    <a:masterClrMapping/>
-  </p:clrMapOvr>
-</p:notes>
-</file>
-
-<file path=ppt/notesSlides/notesSlide11.xml><?xml version="1.0" encoding="utf-8"?>
-<p:notes xmlns:a="http://schemas.openxmlformats.org/drawingml/2006/main" xmlns:p="http://schemas.openxmlformats.org/presentationml/2006/main" xmlns:r="http://schemas.openxmlformats.org/officeDocument/2006/relationships">
-  <p:cSld>
-    <p:spTree>
-      <p:nvGrpSpPr>
-        <p:cNvPr id="1" name=""/>
-        <p:cNvGrpSpPr/>
-        <p:nvPr/>
-      </p:nvGrpSpPr>
-      <p:grpSpPr>
-        <a:xfrm>
-          <a:off x="0" y="0"/>
-          <a:ext cx="0" cy="0"/>
-          <a:chOff x="0" y="0"/>
-          <a:chExt cx="0" cy="0"/>
-        </a:xfrm>
-      </p:grpSpPr>
-      <p:sp>
-        <p:nvSpPr>
-          <p:cNvPr id="2" name="Slide Image Placeholder 1"/>
-          <p:cNvSpPr>
-            <a:spLocks noGrp="1"/>
-          </p:cNvSpPr>
-          <p:nvPr>
-            <p:ph type="sldImg" idx="2"/>
-          </p:nvPr>
-        </p:nvSpPr>
-        <p:spPr/>
-      </p:sp>
-      <p:sp>
-        <p:nvSpPr>
-          <p:cNvPr id="3" name="Notes Placeholder 2"/>
-          <p:cNvSpPr>
-            <a:spLocks noGrp="1"/>
-          </p:cNvSpPr>
-          <p:nvPr>
-            <p:ph type="body" idx="3" sz="quarter"/>
-          </p:nvPr>
-        </p:nvSpPr>
-        <p:spPr/>
-        <p:txBody>
-          <a:bodyPr/>
-          <a:lstStyle/>
-          <a:p>
-            <a:r>
-              <a:t>Moderation (HB Sec 3): Partnerarbeit mit Musterprofil aus Sec 4.3. Aufgabe: Welche Wallet-Share-Lücken erkennen Sie? Welche zwei Ansatzpunkte würden Sie zuerst adressieren? Auswertung im Plenum: Welche Lücken hat jedes Paar identifiziert? Unterschiede in der Priorisierung diskutieren. Trainer-Hinweis: Es gibt keine eindeutig richtige Priorisierung – das ist Absicht. Die Diskussion zeigt, dass systematisches Cross-Selling Urteile erfordert, nicht nur Checklisten. Das ist die Vorbereitung auf Stufe 3 (M14). Trainer-Hinweis Priorisierung: Wenn TN nach unterschiedlichen Kriterien priorisieren (der eine nach Kundenbedarf, der andere nach Abschlusswahrscheinlichkeit): beide Perspektiven würdigen und dann gemeinsam eine Entscheidungsregel ableiten – Anlass-Aktualität + Ertragspotenzial + Beziehungsrisiko. Das Priorisierungsraster aus Arbeitsblatt A (Priorität A vs. B) als gemeinsame Methode festhalten, damit die Übung nicht in beliebigen Einzelmeinungen endet.</a:t>
-            </a:r>
-          </a:p>
-        </p:txBody>
-      </p:sp>
-      <p:sp>
-        <p:nvSpPr>
-          <p:cNvPr id="4" name="Slide Number Placeholder 3"/>
-          <p:cNvSpPr>
-            <a:spLocks noGrp="1"/>
-          </p:cNvSpPr>
-          <p:nvPr>
-            <p:ph type="sldNum" idx="5" sz="quarter"/>
-          </p:nvPr>
-        </p:nvSpPr>
-        <p:spPr/>
-      </p:sp>
-    </p:spTree>
-  </p:cSld>
-  <p:clrMapOvr>
-    <a:masterClrMapping/>
-  </p:clrMapOvr>
-</p:notes>
-</file>
-
 <file path=ppt/notesSlides/notesSlide2.xml><?xml version="1.0" encoding="utf-8"?>
 <p:notes xmlns:a="http://schemas.openxmlformats.org/drawingml/2006/main" xmlns:p="http://schemas.openxmlformats.org/presentationml/2006/main" xmlns:r="http://schemas.openxmlformats.org/officeDocument/2006/relationships">
   <p:cSld>
@@ -728,7 +586,7 @@
           <a:lstStyle/>
           <a:p>
             <a:r>
-              <a:t>Siehe Trainerhandbuch (Sektion 3) für Moderationshinweise, Timing und erwartete Teilnehmerreaktionen.</a:t>
+              <a:t>Einstieg: „Wann hat Ihnen zuletzt jemand etwas verkauft, das Sie nicht brauchten – und wie hat sich das angefühlt?"</a:t>
             </a:r>
           </a:p>
         </p:txBody>
@@ -798,7 +656,7 @@
           <a:lstStyle/>
           <a:p>
             <a:r>
-              <a:t>Siehe Trainerhandbuch (Sektion 3) für Moderationshinweise, Timing und erwartete Teilnehmerreaktionen.</a:t>
+              <a:t>Der Modultitel ist Programm: systematisch heißt bedarfsorientiert, nicht listengetrieben.</a:t>
             </a:r>
           </a:p>
         </p:txBody>
@@ -868,7 +726,7 @@
           <a:lstStyle/>
           <a:p>
             <a:r>
-              <a:t>Siehe Trainerhandbuch (Sektion 3) für Moderationshinweise, Timing und erwartete Teilnehmerreaktionen.</a:t>
+              <a:t>Wallet-Share sichtbar machen: wo ist die Beziehung „flach" – viel Kredit, aber kein Verbundpartner eingebunden?</a:t>
             </a:r>
           </a:p>
         </p:txBody>
@@ -938,7 +796,7 @@
           <a:lstStyle/>
           <a:p>
             <a:r>
-              <a:t>Siehe Trainerhandbuch (Sektion 3) für Moderationshinweise, Timing und erwartete Teilnehmerreaktionen.</a:t>
+              <a:t>Die Hypothese ist der Kern: eine begründete Vermutung über den Bedarf, die im Gespräch geprüft wird.</a:t>
             </a:r>
           </a:p>
         </p:txBody>
@@ -1008,7 +866,12 @@
           <a:lstStyle/>
           <a:p>
             <a:r>
-              <a:t>Siehe Trainerhandbuch (Sektion 3) für Moderationshinweise, Timing und erwartete Teilnehmerreaktionen.</a:t>
+              <a:t>AB Musterlösung (Trainer-Version)</a:t>
+            </a:r>
+          </a:p>
+          <a:p>
+            <a:r>
+              <a:t>Fall Markus Hofer: stabile, aber flache Beziehung (Kontokorrent, Darlehen, ZV; kein Verbund). Einstieg Betriebsunterbrechungsversicherung – weil der Kunde einen zweiwöchigen CNC-Ausfall erwähnte. Anlass schlägt Produktliste.</a:t>
             </a:r>
           </a:p>
         </p:txBody>
@@ -1078,7 +941,7 @@
           <a:lstStyle/>
           <a:p>
             <a:r>
-              <a:t>Moderation (HB Sec 3): Partnerarbeit mit Musterprofil aus Sec 4.3. Aufgabe: Welche Wallet-Share-Lücken erkennen Sie? Welche zwei Ansatzpunkte würden Sie zuerst adressieren? Auswertung im Plenum: Welche Lücken hat jedes Paar identifiziert? Unterschiede in der Priorisierung diskutieren. Trainer-Hinweis: Es gibt keine eindeutig richtige Priorisierung – das ist Absicht. Die Diskussion zeigt, dass systematisches Cross-Selling Urteile erfordert, nicht nur Checklisten. Das ist die Vorbereitung auf Stufe 3 (M14). Trainer-Hinweis Priorisierung: Wenn TN nach unterschiedlichen Kriterien priorisieren (der eine nach Kundenbedarf, der andere nach Abschlusswahrscheinlichkeit): beide Perspektiven würdigen und dann gemeinsam eine Entscheidungsregel ableiten – Anlass-Aktualität + Ertragspotenzial + Beziehungsrisiko. Das Priorisierungsraster aus Arbeitsblatt A (Priorität A vs. B) als gemeinsame Methode festhalten, damit die Übung nicht in beliebigen Einzelmeinungen endet.</a:t>
+              <a:t>Überleitung zum Transfer: eine Hypothese für einen realen Kunden vorbereiten.</a:t>
             </a:r>
           </a:p>
         </p:txBody>
@@ -1148,77 +1011,7 @@
           <a:lstStyle/>
           <a:p>
             <a:r>
-              <a:t>Siehe Trainerhandbuch (Sektion 3) für Moderationshinweise, Timing und erwartete Teilnehmerreaktionen.</a:t>
-            </a:r>
-          </a:p>
-        </p:txBody>
-      </p:sp>
-      <p:sp>
-        <p:nvSpPr>
-          <p:cNvPr id="4" name="Slide Number Placeholder 3"/>
-          <p:cNvSpPr>
-            <a:spLocks noGrp="1"/>
-          </p:cNvSpPr>
-          <p:nvPr>
-            <p:ph type="sldNum" idx="5" sz="quarter"/>
-          </p:nvPr>
-        </p:nvSpPr>
-        <p:spPr/>
-      </p:sp>
-    </p:spTree>
-  </p:cSld>
-  <p:clrMapOvr>
-    <a:masterClrMapping/>
-  </p:clrMapOvr>
-</p:notes>
-</file>
-
-<file path=ppt/notesSlides/notesSlide9.xml><?xml version="1.0" encoding="utf-8"?>
-<p:notes xmlns:a="http://schemas.openxmlformats.org/drawingml/2006/main" xmlns:p="http://schemas.openxmlformats.org/presentationml/2006/main" xmlns:r="http://schemas.openxmlformats.org/officeDocument/2006/relationships">
-  <p:cSld>
-    <p:spTree>
-      <p:nvGrpSpPr>
-        <p:cNvPr id="1" name=""/>
-        <p:cNvGrpSpPr/>
-        <p:nvPr/>
-      </p:nvGrpSpPr>
-      <p:grpSpPr>
-        <a:xfrm>
-          <a:off x="0" y="0"/>
-          <a:ext cx="0" cy="0"/>
-          <a:chOff x="0" y="0"/>
-          <a:chExt cx="0" cy="0"/>
-        </a:xfrm>
-      </p:grpSpPr>
-      <p:sp>
-        <p:nvSpPr>
-          <p:cNvPr id="2" name="Slide Image Placeholder 1"/>
-          <p:cNvSpPr>
-            <a:spLocks noGrp="1"/>
-          </p:cNvSpPr>
-          <p:nvPr>
-            <p:ph type="sldImg" idx="2"/>
-          </p:nvPr>
-        </p:nvSpPr>
-        <p:spPr/>
-      </p:sp>
-      <p:sp>
-        <p:nvSpPr>
-          <p:cNvPr id="3" name="Notes Placeholder 2"/>
-          <p:cNvSpPr>
-            <a:spLocks noGrp="1"/>
-          </p:cNvSpPr>
-          <p:nvPr>
-            <p:ph type="body" idx="3" sz="quarter"/>
-          </p:nvPr>
-        </p:nvSpPr>
-        <p:spPr/>
-        <p:txBody>
-          <a:bodyPr/>
-          <a:lstStyle/>
-          <a:p>
-            <a:r>
-              <a:t>Siehe Trainerhandbuch (Sektion 3) für Moderationshinweise, Timing und erwartete Teilnehmerreaktionen.</a:t>
+              <a:t>Selbstcheck als Transferanker.</a:t>
             </a:r>
           </a:p>
         </p:txBody>
@@ -5036,7 +4829,7 @@
                 </a:solidFill>
                 <a:latin typeface="Arial"/>
               </a:rPr>
-              <a:t>Schritt 1: Analyse</a:t>
+              <a:t>Vier Schritte zum bedarfsgerechten Cross-Selling</a:t>
             </a:r>
           </a:p>
         </p:txBody>
@@ -5062,6 +4855,25 @@
             <a:spAutoFit/>
           </a:bodyPr>
           <a:lstStyle/>
+          <a:p>
+            <a:pPr marL="177800" indent="-177800">
+              <a:spcBef>
+                <a:spcPts val="600"/>
+              </a:spcBef>
+              <a:spcAft>
+                <a:spcPts val="200"/>
+              </a:spcAft>
+            </a:pPr>
+            <a:r>
+              <a:rPr sz="1200" i="1">
+                <a:solidFill>
+                  <a:srgbClr val="3D5466"/>
+                </a:solidFill>
+                <a:latin typeface="Arial"/>
+              </a:rPr>
+              <a:t>→  Systematisches Cross-Selling folgt vier Schritten – nicht dem Zufall des Gesprächsverlaufs.</a:t>
+            </a:r>
+          </a:p>
           <a:p>
             <a:pPr marL="190500" indent="-190500">
               <a:spcBef>
@@ -5078,7 +4890,7 @@
                 </a:solidFill>
                 <a:latin typeface="Arial"/>
               </a:rPr>
-              <a:t>▸  Wer? Welcher Kunde hat das größte unausgeschöpfte Potenzial?</a:t>
+              <a:t>▸  Schritt 1 Analyse: Bestand und Wallet-Share in agree prüfen.</a:t>
             </a:r>
           </a:p>
           <a:p>
@@ -5097,7 +4909,7 @@
                 </a:solidFill>
                 <a:latin typeface="Arial"/>
               </a:rPr>
-              <a:t>▸  Was? In welchem Bedarfsfeld liegt das Potenzial (Finanzierung, Absicherung, Anlage, ZV)?</a:t>
+              <a:t>▸  Schritt 2 Hypothese: konkrete Bedarfshypothese je Kunde formulieren.</a:t>
             </a:r>
           </a:p>
           <a:p>
@@ -5116,7 +4928,7 @@
                 </a:solidFill>
                 <a:latin typeface="Arial"/>
               </a:rPr>
-              <a:t>▸  Datenquellen: agree CRM, Jahreskontospiegel, Kreditakten, Verbundpartner-Cockpit</a:t>
+              <a:t>▸  Schritt 3 Gespräch: die Hypothese als Frage einbringen, nicht als Angebot.</a:t>
             </a:r>
           </a:p>
           <a:p>
@@ -5135,7 +4947,7 @@
                 </a:solidFill>
                 <a:latin typeface="Arial"/>
               </a:rPr>
-              <a:t>▸  Ergebnis: Eine priorisierte Liste von 3–5 Cross-Selling-Hypothesen für diesen Kunden.</a:t>
+              <a:t>▸  Schritt 4 Dokumentation: Ergebnis und nächsten Schritt im System festhalten.</a:t>
             </a:r>
           </a:p>
         </p:txBody>
@@ -5251,7 +5063,7 @@
             <a:avLst/>
           </a:prstGeom>
           <a:solidFill>
-            <a:srgbClr val="EDEDF3"/>
+            <a:srgbClr val="FFFFFF"/>
           </a:solidFill>
           <a:ln>
             <a:noFill/>
@@ -5352,51 +5164,43 @@
                 </a:solidFill>
                 <a:latin typeface="Consolas"/>
               </a:rPr>
-              <a:t>M13  ·  INHALT</a:t>
-            </a:r>
-          </a:p>
-        </p:txBody>
-      </p:sp>
-      <p:sp>
-        <p:nvSpPr>
-          <p:cNvPr id="5" name="Rectangle 4"/>
-          <p:cNvSpPr/>
-          <p:nvPr/>
-        </p:nvSpPr>
-        <p:spPr>
-          <a:xfrm>
-            <a:off x="0" y="1234440"/>
-            <a:ext cx="12188952" cy="12700"/>
-          </a:xfrm>
-          <a:prstGeom prst="rect">
-            <a:avLst/>
-          </a:prstGeom>
-          <a:solidFill>
-            <a:srgbClr val="D8DFE4"/>
-          </a:solidFill>
-          <a:ln>
-            <a:noFill/>
-          </a:ln>
-        </p:spPr>
-        <p:style>
-          <a:lnRef idx="1">
-            <a:schemeClr val="accent1"/>
-          </a:lnRef>
-          <a:fillRef idx="3">
-            <a:schemeClr val="accent1"/>
-          </a:fillRef>
-          <a:effectRef idx="2">
-            <a:schemeClr val="accent1"/>
-          </a:effectRef>
-          <a:fontRef idx="minor">
-            <a:schemeClr val="lt1"/>
-          </a:fontRef>
-        </p:style>
-        <p:txBody>
-          <a:bodyPr rtlCol="0" anchor="ctr"/>
-          <a:lstStyle/>
-          <a:p>
-            <a:pPr algn="ctr"/>
+              <a:t>M13  ·  SCHAUBILD</a:t>
+            </a:r>
+          </a:p>
+        </p:txBody>
+      </p:sp>
+      <p:sp>
+        <p:nvSpPr>
+          <p:cNvPr id="5" name="TextBox 4"/>
+          <p:cNvSpPr txBox="1"/>
+          <p:nvPr/>
+        </p:nvSpPr>
+        <p:spPr>
+          <a:xfrm>
+            <a:off x="685800" y="502920"/>
+            <a:ext cx="10817352" cy="594360"/>
+          </a:xfrm>
+          <a:prstGeom prst="rect">
+            <a:avLst/>
+          </a:prstGeom>
+          <a:noFill/>
+        </p:spPr>
+        <p:txBody>
+          <a:bodyPr wrap="square">
+            <a:spAutoFit/>
+          </a:bodyPr>
+          <a:lstStyle/>
+          <a:p>
+            <a:pPr algn="l"/>
+            <a:r>
+              <a:rPr sz="2000" b="1" i="0">
+                <a:solidFill>
+                  <a:srgbClr val="1F2C56"/>
+                </a:solidFill>
+                <a:latin typeface="Arial"/>
+              </a:rPr>
+              <a:t>Verbundpartner-Matrix: welcher Bedarf, welcher Partner</a:t>
+            </a:r>
           </a:p>
         </p:txBody>
       </p:sp>
@@ -5408,8 +5212,8 @@
         </p:nvSpPr>
         <p:spPr>
           <a:xfrm>
-            <a:off x="685800" y="502920"/>
-            <a:ext cx="36576" cy="658368"/>
+            <a:off x="685800" y="1143000"/>
+            <a:ext cx="10817352" cy="25400"/>
           </a:xfrm>
           <a:prstGeom prst="rect">
             <a:avLst/>
@@ -5443,105 +5247,33 @@
           </a:p>
         </p:txBody>
       </p:sp>
-      <p:sp>
-        <p:nvSpPr>
-          <p:cNvPr id="7" name="TextBox 6"/>
-          <p:cNvSpPr txBox="1"/>
-          <p:nvPr/>
-        </p:nvSpPr>
-        <p:spPr>
-          <a:xfrm>
-            <a:off x="813816" y="502920"/>
-            <a:ext cx="10634472" cy="685800"/>
-          </a:xfrm>
-          <a:prstGeom prst="rect">
-            <a:avLst/>
-          </a:prstGeom>
-          <a:noFill/>
-        </p:spPr>
-        <p:txBody>
-          <a:bodyPr wrap="square">
-            <a:spAutoFit/>
-          </a:bodyPr>
-          <a:lstStyle/>
-          <a:p>
-            <a:pPr algn="l"/>
-            <a:r>
-              <a:rPr sz="2400" b="1" i="0">
-                <a:solidFill>
-                  <a:srgbClr val="1F2C56"/>
-                </a:solidFill>
-                <a:latin typeface="Arial"/>
-              </a:rPr>
-              <a:t>Schritt 2: Hypothese formulieren</a:t>
-            </a:r>
-          </a:p>
-        </p:txBody>
-      </p:sp>
-      <p:sp>
-        <p:nvSpPr>
-          <p:cNvPr id="8" name="TextBox 7"/>
-          <p:cNvSpPr txBox="1"/>
-          <p:nvPr/>
-        </p:nvSpPr>
-        <p:spPr>
-          <a:xfrm>
-            <a:off x="685800" y="1417320"/>
-            <a:ext cx="10817352" cy="4892040"/>
-          </a:xfrm>
-          <a:prstGeom prst="rect">
-            <a:avLst/>
-          </a:prstGeom>
-          <a:noFill/>
-        </p:spPr>
-        <p:txBody>
-          <a:bodyPr wrap="square" anchor="ctr">
-            <a:spAutoFit/>
-          </a:bodyPr>
-          <a:lstStyle/>
-          <a:p>
-            <a:pPr marL="190500" indent="-190500">
-              <a:spcBef>
-                <a:spcPts val="400"/>
-              </a:spcBef>
-              <a:spcAft>
-                <a:spcPts val="200"/>
-              </a:spcAft>
-            </a:pPr>
-            <a:r>
-              <a:rPr sz="1300">
-                <a:solidFill>
-                  <a:srgbClr val="3D5466"/>
-                </a:solidFill>
-                <a:latin typeface="Arial"/>
-              </a:rPr>
-              <a:t>▸  Eine Cross-Selling-Hypothese verknüpft einen beobachteten Kundenbedarf mit einem konkreten Lösungsansatz. Gutes Format:</a:t>
-            </a:r>
-          </a:p>
-          <a:p>
-            <a:pPr marL="177800" indent="-177800">
-              <a:spcBef>
-                <a:spcPts val="600"/>
-              </a:spcBef>
-              <a:spcAft>
-                <a:spcPts val="200"/>
-              </a:spcAft>
-            </a:pPr>
-            <a:r>
-              <a:rPr sz="1200" i="1">
-                <a:solidFill>
-                  <a:srgbClr val="3D5466"/>
-                </a:solidFill>
-                <a:latin typeface="Arial"/>
-              </a:rPr>
-              <a:t>→  „[Kunde] hat [Situation/Signal]. Ich vermute deshalb, dass er [Bedarf] hat – passend dazu wäre [Lösung/Verbundpartner]."</a:t>
-            </a:r>
-          </a:p>
-        </p:txBody>
-      </p:sp>
-      <p:sp>
-        <p:nvSpPr>
-          <p:cNvPr id="9" name="Rectangle 8"/>
+      <p:pic>
+        <p:nvPicPr>
+          <p:cNvPr id="7" name="Picture 6" descr="image.png"/>
+          <p:cNvPicPr>
+            <a:picLocks noChangeAspect="1"/>
+          </p:cNvPicPr>
+          <p:nvPr/>
+        </p:nvPicPr>
+        <p:blipFill>
+          <a:blip r:embed="rId2"/>
+          <a:stretch>
+            <a:fillRect/>
+          </a:stretch>
+        </p:blipFill>
+        <p:spPr>
+          <a:xfrm>
+            <a:off x="2433486" y="1325880"/>
+            <a:ext cx="7321979" cy="4937760"/>
+          </a:xfrm>
+          <a:prstGeom prst="rect">
+            <a:avLst/>
+          </a:prstGeom>
+        </p:spPr>
+      </p:pic>
+      <p:sp>
+        <p:nvSpPr>
+          <p:cNvPr id="8" name="Rectangle 7"/>
           <p:cNvSpPr/>
           <p:nvPr/>
         </p:nvSpPr>
@@ -5584,7 +5316,7 @@
       </p:sp>
       <p:sp>
         <p:nvSpPr>
-          <p:cNvPr id="10" name="TextBox 9"/>
+          <p:cNvPr id="9" name="TextBox 8"/>
           <p:cNvSpPr txBox="1"/>
           <p:nvPr/>
         </p:nvSpPr>
@@ -5613,6 +5345,41 @@
                 <a:latin typeface="Consolas"/>
               </a:rPr>
               <a:t>FKB Campus  ·  M13</a:t>
+            </a:r>
+          </a:p>
+        </p:txBody>
+      </p:sp>
+      <p:sp>
+        <p:nvSpPr>
+          <p:cNvPr id="10" name="TextBox 9"/>
+          <p:cNvSpPr txBox="1"/>
+          <p:nvPr/>
+        </p:nvSpPr>
+        <p:spPr>
+          <a:xfrm>
+            <a:off x="7176211" y="6583680"/>
+            <a:ext cx="4326940" cy="256032"/>
+          </a:xfrm>
+          <a:prstGeom prst="rect">
+            <a:avLst/>
+          </a:prstGeom>
+          <a:noFill/>
+        </p:spPr>
+        <p:txBody>
+          <a:bodyPr wrap="none">
+            <a:spAutoFit/>
+          </a:bodyPr>
+          <a:lstStyle/>
+          <a:p>
+            <a:pPr algn="r"/>
+            <a:r>
+              <a:rPr sz="700">
+                <a:solidFill>
+                  <a:srgbClr val="A0B4D2"/>
+                </a:solidFill>
+                <a:latin typeface="Consolas"/>
+              </a:rPr>
+              <a:t>Schaubild</a:t>
             </a:r>
           </a:p>
         </p:txBody>
@@ -5650,7 +5417,7 @@
             <a:avLst/>
           </a:prstGeom>
           <a:solidFill>
-            <a:srgbClr val="EDEDF3"/>
+            <a:srgbClr val="1F2C56"/>
           </a:solidFill>
           <a:ln>
             <a:noFill/>
@@ -5680,57 +5447,14 @@
       </p:sp>
       <p:sp>
         <p:nvSpPr>
-          <p:cNvPr id="3" name="Rectangle 2"/>
-          <p:cNvSpPr/>
-          <p:nvPr/>
-        </p:nvSpPr>
-        <p:spPr>
-          <a:xfrm>
-            <a:off x="0" y="0"/>
-            <a:ext cx="12188952" cy="50292"/>
-          </a:xfrm>
-          <a:prstGeom prst="rect">
-            <a:avLst/>
-          </a:prstGeom>
-          <a:solidFill>
-            <a:srgbClr val="1F2C56"/>
-          </a:solidFill>
-          <a:ln>
-            <a:noFill/>
-          </a:ln>
-        </p:spPr>
-        <p:style>
-          <a:lnRef idx="1">
-            <a:schemeClr val="accent1"/>
-          </a:lnRef>
-          <a:fillRef idx="3">
-            <a:schemeClr val="accent1"/>
-          </a:fillRef>
-          <a:effectRef idx="2">
-            <a:schemeClr val="accent1"/>
-          </a:effectRef>
-          <a:fontRef idx="minor">
-            <a:schemeClr val="lt1"/>
-          </a:fontRef>
-        </p:style>
-        <p:txBody>
-          <a:bodyPr rtlCol="0" anchor="ctr"/>
-          <a:lstStyle/>
-          <a:p>
-            <a:pPr algn="ctr"/>
-          </a:p>
-        </p:txBody>
-      </p:sp>
-      <p:sp>
-        <p:nvSpPr>
-          <p:cNvPr id="4" name="TextBox 3"/>
+          <p:cNvPr id="3" name="TextBox 2"/>
           <p:cNvSpPr txBox="1"/>
           <p:nvPr/>
         </p:nvSpPr>
         <p:spPr>
           <a:xfrm>
-            <a:off x="685800" y="109728"/>
-            <a:ext cx="10817352" cy="228600"/>
+            <a:off x="685800" y="2377440"/>
+            <a:ext cx="10817352" cy="365760"/>
           </a:xfrm>
           <a:prstGeom prst="rect">
             <a:avLst/>
@@ -5745,70 +5469,27 @@
           <a:p>
             <a:pPr algn="l"/>
             <a:r>
-              <a:rPr sz="750">
-                <a:solidFill>
-                  <a:srgbClr val="78808C"/>
+              <a:rPr sz="1200">
+                <a:solidFill>
+                  <a:srgbClr val="D9C089"/>
                 </a:solidFill>
                 <a:latin typeface="Consolas"/>
               </a:rPr>
-              <a:t>M13  ·  INHALT</a:t>
-            </a:r>
-          </a:p>
-        </p:txBody>
-      </p:sp>
-      <p:sp>
-        <p:nvSpPr>
-          <p:cNvPr id="5" name="Rectangle 4"/>
+              <a:t>FALLARBEIT</a:t>
+            </a:r>
+          </a:p>
+        </p:txBody>
+      </p:sp>
+      <p:sp>
+        <p:nvSpPr>
+          <p:cNvPr id="4" name="Rectangle 3"/>
           <p:cNvSpPr/>
           <p:nvPr/>
         </p:nvSpPr>
         <p:spPr>
           <a:xfrm>
-            <a:off x="0" y="1234440"/>
-            <a:ext cx="12188952" cy="12700"/>
-          </a:xfrm>
-          <a:prstGeom prst="rect">
-            <a:avLst/>
-          </a:prstGeom>
-          <a:solidFill>
-            <a:srgbClr val="D8DFE4"/>
-          </a:solidFill>
-          <a:ln>
-            <a:noFill/>
-          </a:ln>
-        </p:spPr>
-        <p:style>
-          <a:lnRef idx="1">
-            <a:schemeClr val="accent1"/>
-          </a:lnRef>
-          <a:fillRef idx="3">
-            <a:schemeClr val="accent1"/>
-          </a:fillRef>
-          <a:effectRef idx="2">
-            <a:schemeClr val="accent1"/>
-          </a:effectRef>
-          <a:fontRef idx="minor">
-            <a:schemeClr val="lt1"/>
-          </a:fontRef>
-        </p:style>
-        <p:txBody>
-          <a:bodyPr rtlCol="0" anchor="ctr"/>
-          <a:lstStyle/>
-          <a:p>
-            <a:pPr algn="ctr"/>
-          </a:p>
-        </p:txBody>
-      </p:sp>
-      <p:sp>
-        <p:nvSpPr>
-          <p:cNvPr id="6" name="Rectangle 5"/>
-          <p:cNvSpPr/>
-          <p:nvPr/>
-        </p:nvSpPr>
-        <p:spPr>
-          <a:xfrm>
-            <a:off x="685800" y="502920"/>
-            <a:ext cx="36576" cy="658368"/>
+            <a:off x="685800" y="2788920"/>
+            <a:ext cx="548640" cy="38100"/>
           </a:xfrm>
           <a:prstGeom prst="rect">
             <a:avLst/>
@@ -5844,14 +5525,14 @@
       </p:sp>
       <p:sp>
         <p:nvSpPr>
-          <p:cNvPr id="7" name="TextBox 6"/>
+          <p:cNvPr id="5" name="TextBox 4"/>
           <p:cNvSpPr txBox="1"/>
           <p:nvPr/>
         </p:nvSpPr>
         <p:spPr>
           <a:xfrm>
-            <a:off x="813816" y="502920"/>
-            <a:ext cx="10634472" cy="685800"/>
+            <a:off x="685800" y="3017520"/>
+            <a:ext cx="10817352" cy="1463040"/>
           </a:xfrm>
           <a:prstGeom prst="rect">
             <a:avLst/>
@@ -5866,27 +5547,27 @@
           <a:p>
             <a:pPr algn="l"/>
             <a:r>
-              <a:rPr sz="2400" b="1" i="0">
-                <a:solidFill>
-                  <a:srgbClr val="1F2C56"/>
+              <a:rPr sz="4000" b="1" i="0">
+                <a:solidFill>
+                  <a:srgbClr val="FFFFFF"/>
                 </a:solidFill>
                 <a:latin typeface="Arial"/>
               </a:rPr>
-              <a:t>Schritt 3: Gespräch</a:t>
-            </a:r>
-          </a:p>
-        </p:txBody>
-      </p:sp>
-      <p:sp>
-        <p:nvSpPr>
-          <p:cNvPr id="8" name="TextBox 7"/>
+              <a:t>Praxiscase: vom Kredit zum Vollbankverbund</a:t>
+            </a:r>
+          </a:p>
+        </p:txBody>
+      </p:sp>
+      <p:sp>
+        <p:nvSpPr>
+          <p:cNvPr id="6" name="TextBox 5"/>
           <p:cNvSpPr txBox="1"/>
           <p:nvPr/>
         </p:nvSpPr>
         <p:spPr>
           <a:xfrm>
-            <a:off x="685800" y="1417320"/>
-            <a:ext cx="10817352" cy="4892040"/>
+            <a:off x="685800" y="4480560"/>
+            <a:ext cx="8653881" cy="1280160"/>
           </a:xfrm>
           <a:prstGeom prst="rect">
             <a:avLst/>
@@ -5899,193 +5580,29 @@
           </a:bodyPr>
           <a:lstStyle/>
           <a:p>
-            <a:pPr marL="190500" indent="-190500">
-              <a:spcBef>
-                <a:spcPts val="400"/>
-              </a:spcBef>
-              <a:spcAft>
-                <a:spcPts val="200"/>
-              </a:spcAft>
-            </a:pPr>
-            <a:r>
-              <a:rPr sz="1300">
-                <a:solidFill>
-                  <a:srgbClr val="3D5466"/>
+            <a:pPr algn="l"/>
+            <a:r>
+              <a:rPr sz="1600" b="0" i="0">
+                <a:solidFill>
+                  <a:srgbClr val="C8D2E6"/>
                 </a:solidFill>
                 <a:latin typeface="Arial"/>
               </a:rPr>
-              <a:t>▸  Das Cross-Selling-Gespräch ist kein Verkaufsgespräch. Es ist eine bedarfsgeleitete Gesprächserweiterung. Der Einstieg erfolgt über eine offene Frage zur Situation – nicht mit einem Produktvorschlag.</a:t>
-            </a:r>
-          </a:p>
-          <a:p>
-            <a:pPr marL="190500" indent="-190500">
-              <a:spcBef>
-                <a:spcPts val="400"/>
-              </a:spcBef>
-              <a:spcAft>
-                <a:spcPts val="200"/>
-              </a:spcAft>
-            </a:pPr>
-            <a:r>
-              <a:rPr sz="1300">
-                <a:solidFill>
-                  <a:srgbClr val="3D5466"/>
-                </a:solidFill>
-                <a:latin typeface="Arial"/>
-              </a:rPr>
-              <a:t>▸  Gesprächseinstieg nach SPIN :</a:t>
-            </a:r>
-          </a:p>
-          <a:p>
-            <a:pPr marL="190500" indent="-190500">
-              <a:spcBef>
-                <a:spcPts val="400"/>
-              </a:spcBef>
-              <a:spcAft>
-                <a:spcPts val="200"/>
-              </a:spcAft>
-            </a:pPr>
-            <a:r>
-              <a:rPr sz="1300">
-                <a:solidFill>
-                  <a:srgbClr val="3D5466"/>
-                </a:solidFill>
-                <a:latin typeface="Arial"/>
-              </a:rPr>
-              <a:t>▸  Situationsfrage: „Wie haben Sie aktuell Ihre Betriebsunterbrechungsrisiken abgesichert?"</a:t>
-            </a:r>
-          </a:p>
-          <a:p>
-            <a:pPr marL="190500" indent="-190500">
-              <a:spcBef>
-                <a:spcPts val="400"/>
-              </a:spcBef>
-              <a:spcAft>
-                <a:spcPts val="200"/>
-              </a:spcAft>
-            </a:pPr>
-            <a:r>
-              <a:rPr sz="1300">
-                <a:solidFill>
-                  <a:srgbClr val="3D5466"/>
-                </a:solidFill>
-                <a:latin typeface="Arial"/>
-              </a:rPr>
-              <a:t>▸  Problemfrage: „Gibt es Bereiche, bei denen Sie sich fragen, ob das ausreicht?"</a:t>
-            </a:r>
-          </a:p>
-          <a:p>
-            <a:pPr marL="190500" indent="-190500">
-              <a:spcBef>
-                <a:spcPts val="400"/>
-              </a:spcBef>
-              <a:spcAft>
-                <a:spcPts val="200"/>
-              </a:spcAft>
-            </a:pPr>
-            <a:r>
-              <a:rPr sz="1300">
-                <a:solidFill>
-                  <a:srgbClr val="3D5466"/>
-                </a:solidFill>
-                <a:latin typeface="Arial"/>
-              </a:rPr>
-              <a:t>▸  Implikationsfrage: „Was würde ein Ausfall von zwei Wochen für Ihren Betrieb bedeuten?"</a:t>
-            </a:r>
-          </a:p>
-          <a:p>
-            <a:pPr marL="190500" indent="-190500">
-              <a:spcBef>
-                <a:spcPts val="400"/>
-              </a:spcBef>
-              <a:spcAft>
-                <a:spcPts val="200"/>
-              </a:spcAft>
-            </a:pPr>
-            <a:r>
-              <a:rPr sz="1300">
-                <a:solidFill>
-                  <a:srgbClr val="3D5466"/>
-                </a:solidFill>
-                <a:latin typeface="Arial"/>
-              </a:rPr>
-              <a:t>▸  Nutzenfrage: „Was wäre für Sie die ideale Lösung, wenn das Risiko vollständig gedeckt wäre?"</a:t>
-            </a:r>
-          </a:p>
-          <a:p>
-            <a:pPr marL="190500" indent="-190500">
-              <a:spcBef>
-                <a:spcPts val="400"/>
-              </a:spcBef>
-              <a:spcAft>
-                <a:spcPts val="200"/>
-              </a:spcAft>
-            </a:pPr>
-            <a:r>
-              <a:rPr sz="1300">
-                <a:solidFill>
-                  <a:srgbClr val="3D5466"/>
-                </a:solidFill>
-                <a:latin typeface="Arial"/>
-              </a:rPr>
-              <a:t>▸  Erst nach diesem Verlauf folgt der Produktvorschlag – oder die Einbeziehung des Verbundpartners.</a:t>
-            </a:r>
-          </a:p>
-        </p:txBody>
-      </p:sp>
-      <p:sp>
-        <p:nvSpPr>
-          <p:cNvPr id="9" name="Rectangle 8"/>
-          <p:cNvSpPr/>
-          <p:nvPr/>
-        </p:nvSpPr>
-        <p:spPr>
-          <a:xfrm>
-            <a:off x="0" y="6510528"/>
-            <a:ext cx="12188952" cy="347472"/>
-          </a:xfrm>
-          <a:prstGeom prst="rect">
-            <a:avLst/>
-          </a:prstGeom>
-          <a:solidFill>
-            <a:srgbClr val="0A1937"/>
-          </a:solidFill>
-          <a:ln>
-            <a:noFill/>
-          </a:ln>
-        </p:spPr>
-        <p:style>
-          <a:lnRef idx="1">
-            <a:schemeClr val="accent1"/>
-          </a:lnRef>
-          <a:fillRef idx="3">
-            <a:schemeClr val="accent1"/>
-          </a:fillRef>
-          <a:effectRef idx="2">
-            <a:schemeClr val="accent1"/>
-          </a:effectRef>
-          <a:fontRef idx="minor">
-            <a:schemeClr val="lt1"/>
-          </a:fontRef>
-        </p:style>
-        <p:txBody>
-          <a:bodyPr rtlCol="0" anchor="ctr"/>
-          <a:lstStyle/>
-          <a:p>
-            <a:pPr algn="ctr"/>
-          </a:p>
-        </p:txBody>
-      </p:sp>
-      <p:sp>
-        <p:nvSpPr>
-          <p:cNvPr id="10" name="TextBox 9"/>
+              <a:t>Aus einer flachen Kreditbeziehung eine Verbundbeziehung entwickeln.</a:t>
+            </a:r>
+          </a:p>
+        </p:txBody>
+      </p:sp>
+      <p:sp>
+        <p:nvSpPr>
+          <p:cNvPr id="7" name="TextBox 6"/>
           <p:cNvSpPr txBox="1"/>
           <p:nvPr/>
         </p:nvSpPr>
         <p:spPr>
           <a:xfrm>
-            <a:off x="685800" y="6583680"/>
-            <a:ext cx="6490411" cy="256032"/>
+            <a:off x="685800" y="6355080"/>
+            <a:ext cx="10817352" cy="274320"/>
           </a:xfrm>
           <a:prstGeom prst="rect">
             <a:avLst/>
@@ -6102,7 +5619,7 @@
             <a:r>
               <a:rPr sz="700">
                 <a:solidFill>
-                  <a:srgbClr val="A0B4D2"/>
+                  <a:srgbClr val="8CA0C3"/>
                 </a:solidFill>
                 <a:latin typeface="Consolas"/>
               </a:rPr>
@@ -6245,7 +5762,7 @@
                 </a:solidFill>
                 <a:latin typeface="Consolas"/>
               </a:rPr>
-              <a:t>M13  ·  INHALT</a:t>
+              <a:t>M13  ·  ARBEITSBLATT</a:t>
             </a:r>
           </a:p>
         </p:txBody>
@@ -6366,7 +5883,7 @@
                 </a:solidFill>
                 <a:latin typeface="Arial"/>
               </a:rPr>
-              <a:t>Schritt 4: Dokumentation</a:t>
+              <a:t>Praxiscase Maschinenbauzulieferer bearbeiten</a:t>
             </a:r>
           </a:p>
         </p:txBody>
@@ -6379,8 +5896,8 @@
         </p:nvSpPr>
         <p:spPr>
           <a:xfrm>
-            <a:off x="685800" y="1417320"/>
-            <a:ext cx="10817352" cy="4892040"/>
+            <a:off x="685800" y="1554480"/>
+            <a:ext cx="10817352" cy="3840480"/>
           </a:xfrm>
           <a:prstGeom prst="rect">
             <a:avLst/>
@@ -6402,13 +5919,13 @@
               </a:spcAft>
             </a:pPr>
             <a:r>
-              <a:rPr sz="1300">
+              <a:rPr sz="1400">
                 <a:solidFill>
                   <a:srgbClr val="3D5466"/>
                 </a:solidFill>
                 <a:latin typeface="Arial"/>
               </a:rPr>
-              <a:t>▸  Besprochene Bedarfsfelder</a:t>
+              <a:t>▸  Analysieren Sie den Wallet-Share des Kunden in agree (AB-1).</a:t>
             </a:r>
           </a:p>
           <a:p>
@@ -6421,13 +5938,13 @@
               </a:spcAft>
             </a:pPr>
             <a:r>
-              <a:rPr sz="1300">
+              <a:rPr sz="1400">
                 <a:solidFill>
                   <a:srgbClr val="3D5466"/>
                 </a:solidFill>
                 <a:latin typeface="Arial"/>
               </a:rPr>
-              <a:t>▸  Ergebnis (Abschluss / offen / kein Bedarf)</a:t>
+              <a:t>▸  Formulieren Sie drei begründete Cross-Selling-Hypothesen.</a:t>
             </a:r>
           </a:p>
           <a:p>
@@ -6440,191 +5957,98 @@
               </a:spcAft>
             </a:pPr>
             <a:r>
-              <a:rPr sz="1300">
+              <a:rPr sz="1400">
                 <a:solidFill>
                   <a:srgbClr val="3D5466"/>
                 </a:solidFill>
                 <a:latin typeface="Arial"/>
               </a:rPr>
-              <a:t>▸  Nächste Schritte und Folgetermine</a:t>
-            </a:r>
-          </a:p>
-          <a:p>
-            <a:pPr marL="190500" indent="-190500">
-              <a:spcBef>
-                <a:spcPts val="400"/>
-              </a:spcBef>
-              <a:spcAft>
-                <a:spcPts val="200"/>
-              </a:spcAft>
-            </a:pPr>
-            <a:r>
-              <a:rPr sz="1300">
-                <a:solidFill>
-                  <a:srgbClr val="3D5466"/>
+              <a:t>▸  Bereiten Sie das Jahresgespräch vor: welche Hypothese als Einstieg, mit welcher Frage? (AB-2)</a:t>
+            </a:r>
+          </a:p>
+        </p:txBody>
+      </p:sp>
+      <p:sp>
+        <p:nvSpPr>
+          <p:cNvPr id="9" name="Rectangle 8"/>
+          <p:cNvSpPr/>
+          <p:nvPr/>
+        </p:nvSpPr>
+        <p:spPr>
+          <a:xfrm>
+            <a:off x="685800" y="5486400"/>
+            <a:ext cx="10817352" cy="640080"/>
+          </a:xfrm>
+          <a:prstGeom prst="rect">
+            <a:avLst/>
+          </a:prstGeom>
+          <a:solidFill>
+            <a:srgbClr val="1F2C56"/>
+          </a:solidFill>
+          <a:ln>
+            <a:noFill/>
+          </a:ln>
+        </p:spPr>
+        <p:style>
+          <a:lnRef idx="1">
+            <a:schemeClr val="accent1"/>
+          </a:lnRef>
+          <a:fillRef idx="3">
+            <a:schemeClr val="accent1"/>
+          </a:fillRef>
+          <a:effectRef idx="2">
+            <a:schemeClr val="accent1"/>
+          </a:effectRef>
+          <a:fontRef idx="minor">
+            <a:schemeClr val="lt1"/>
+          </a:fontRef>
+        </p:style>
+        <p:txBody>
+          <a:bodyPr rtlCol="0" anchor="ctr"/>
+          <a:lstStyle/>
+          <a:p>
+            <a:pPr algn="ctr"/>
+          </a:p>
+        </p:txBody>
+      </p:sp>
+      <p:sp>
+        <p:nvSpPr>
+          <p:cNvPr id="10" name="TextBox 9"/>
+          <p:cNvSpPr txBox="1"/>
+          <p:nvPr/>
+        </p:nvSpPr>
+        <p:spPr>
+          <a:xfrm>
+            <a:off x="868680" y="5596128"/>
+            <a:ext cx="10451592" cy="457200"/>
+          </a:xfrm>
+          <a:prstGeom prst="rect">
+            <a:avLst/>
+          </a:prstGeom>
+          <a:noFill/>
+        </p:spPr>
+        <p:txBody>
+          <a:bodyPr wrap="square">
+            <a:spAutoFit/>
+          </a:bodyPr>
+          <a:lstStyle/>
+          <a:p>
+            <a:pPr algn="l"/>
+            <a:r>
+              <a:rPr sz="1300" b="1" i="0">
+                <a:solidFill>
+                  <a:srgbClr val="FFFFFF"/>
                 </a:solidFill>
                 <a:latin typeface="Arial"/>
               </a:rPr>
-              <a:t>▸  Verbundpartner-Übergabe (falls relevant)</a:t>
-            </a:r>
-          </a:p>
-          <a:p>
-            <a:pPr marL="190500" indent="-190500">
-              <a:spcBef>
-                <a:spcPts val="400"/>
-              </a:spcBef>
-              <a:spcAft>
-                <a:spcPts val="200"/>
-              </a:spcAft>
-            </a:pPr>
-            <a:r>
-              <a:rPr sz="1300">
-                <a:solidFill>
-                  <a:srgbClr val="3D5466"/>
-                </a:solidFill>
-                <a:latin typeface="Arial"/>
-              </a:rPr>
-              <a:t>▸  ## 4.4 Verbundpartner-Matrix</a:t>
-            </a:r>
-          </a:p>
-          <a:p>
-            <a:pPr marL="190500" indent="-190500">
-              <a:spcBef>
-                <a:spcPts val="400"/>
-              </a:spcBef>
-              <a:spcAft>
-                <a:spcPts val="200"/>
-              </a:spcAft>
-            </a:pPr>
-            <a:r>
-              <a:rPr sz="1300">
-                <a:solidFill>
-                  <a:srgbClr val="3D5466"/>
-                </a:solidFill>
-                <a:latin typeface="Arial"/>
-              </a:rPr>
-              <a:t>▸  Die Stärke der VR-Bank liegt im Verbund. Welcher Verbundpartner ist für welches Bedarfsfeld relevant?</a:t>
-            </a:r>
-          </a:p>
-          <a:p>
-            <a:pPr marL="190500" indent="-190500">
-              <a:spcBef>
-                <a:spcPts val="400"/>
-              </a:spcBef>
-              <a:spcAft>
-                <a:spcPts val="200"/>
-              </a:spcAft>
-            </a:pPr>
-            <a:r>
-              <a:rPr sz="1300">
-                <a:solidFill>
-                  <a:srgbClr val="3D5466"/>
-                </a:solidFill>
-                <a:latin typeface="Arial"/>
-              </a:rPr>
-              <a:t>▸  ## 4.5 Praxiscase: Vom Kreditgespräch zum Vollbankverbund</a:t>
-            </a:r>
-          </a:p>
-          <a:p>
-            <a:pPr marL="190500" indent="-190500">
-              <a:spcBef>
-                <a:spcPts val="400"/>
-              </a:spcBef>
-              <a:spcAft>
-                <a:spcPts val="200"/>
-              </a:spcAft>
-            </a:pPr>
-            <a:r>
-              <a:rPr sz="1300">
-                <a:solidFill>
-                  <a:srgbClr val="3D5466"/>
-                </a:solidFill>
-                <a:latin typeface="Arial"/>
-              </a:rPr>
-              <a:t>▸  Ausgangssituation</a:t>
-            </a:r>
-          </a:p>
-          <a:p>
-            <a:pPr marL="190500" indent="-190500">
-              <a:spcBef>
-                <a:spcPts val="400"/>
-              </a:spcBef>
-              <a:spcAft>
-                <a:spcPts val="200"/>
-              </a:spcAft>
-            </a:pPr>
-            <a:r>
-              <a:rPr sz="1300">
-                <a:solidFill>
-                  <a:srgbClr val="3D5466"/>
-                </a:solidFill>
-                <a:latin typeface="Arial"/>
-              </a:rPr>
-              <a:t>▸  Vor dem Jahresgespräch analysiert Markus den Kunden in agree:</a:t>
-            </a:r>
-          </a:p>
-          <a:p>
-            <a:pPr marL="190500" indent="-190500">
-              <a:spcBef>
-                <a:spcPts val="400"/>
-              </a:spcBef>
-              <a:spcAft>
-                <a:spcPts val="200"/>
-              </a:spcAft>
-            </a:pPr>
-            <a:r>
-              <a:rPr sz="1300">
-                <a:solidFill>
-                  <a:srgbClr val="3D5466"/>
-                </a:solidFill>
-                <a:latin typeface="Arial"/>
-              </a:rPr>
-              <a:t>▸  Das Gespräch</a:t>
-            </a:r>
-          </a:p>
-          <a:p>
-            <a:pPr marL="190500" indent="-190500">
-              <a:spcBef>
-                <a:spcPts val="400"/>
-              </a:spcBef>
-              <a:spcAft>
-                <a:spcPts val="200"/>
-              </a:spcAft>
-            </a:pPr>
-            <a:r>
-              <a:rPr sz="1300">
-                <a:solidFill>
-                  <a:srgbClr val="3D5466"/>
-                </a:solidFill>
-                <a:latin typeface="Arial"/>
-              </a:rPr>
-              <a:t>▸  „Sie hatten letztes Jahr den Ausfall der CNC-Anlage erwähnt. Wie haben Sie die zwei Wochen finanziell abgefedert?"</a:t>
-            </a:r>
-          </a:p>
-          <a:p>
-            <a:pPr marL="190500" indent="-190500">
-              <a:spcBef>
-                <a:spcPts val="400"/>
-              </a:spcBef>
-              <a:spcAft>
-                <a:spcPts val="200"/>
-              </a:spcAft>
-            </a:pPr>
-            <a:r>
-              <a:rPr sz="1300">
-                <a:solidFill>
-                  <a:srgbClr val="3D5466"/>
-                </a:solidFill>
-                <a:latin typeface="Arial"/>
-              </a:rPr>
-              <a:t>▸  Der Kunde: „Ehrlich gesagt war das eng. Wir haben aus den Rücklagen überbrückt – aber das war ungeplant."</a:t>
-            </a:r>
-          </a:p>
-        </p:txBody>
-      </p:sp>
-      <p:sp>
-        <p:nvSpPr>
-          <p:cNvPr id="9" name="Rectangle 8"/>
+              <a:t>→  Bearbeitung im Teilnehmer-Workbook (Arbeitsblatt mit Ausfüllfeldern)</a:t>
+            </a:r>
+          </a:p>
+        </p:txBody>
+      </p:sp>
+      <p:sp>
+        <p:nvSpPr>
+          <p:cNvPr id="11" name="Rectangle 10"/>
           <p:cNvSpPr/>
           <p:nvPr/>
         </p:nvSpPr>
@@ -6667,7 +6091,7 @@
       </p:sp>
       <p:sp>
         <p:nvSpPr>
-          <p:cNvPr id="10" name="TextBox 9"/>
+          <p:cNvPr id="12" name="TextBox 11"/>
           <p:cNvSpPr txBox="1"/>
           <p:nvPr/>
         </p:nvSpPr>
@@ -6733,7 +6157,7 @@
             <a:avLst/>
           </a:prstGeom>
           <a:solidFill>
-            <a:srgbClr val="FFFFFF"/>
+            <a:srgbClr val="EDEDF3"/>
           </a:solidFill>
           <a:ln>
             <a:noFill/>
@@ -6834,43 +6258,51 @@
                 </a:solidFill>
                 <a:latin typeface="Consolas"/>
               </a:rPr>
-              <a:t>M13  ·  SCHAUBILD</a:t>
-            </a:r>
-          </a:p>
-        </p:txBody>
-      </p:sp>
-      <p:sp>
-        <p:nvSpPr>
-          <p:cNvPr id="5" name="TextBox 4"/>
-          <p:cNvSpPr txBox="1"/>
-          <p:nvPr/>
-        </p:nvSpPr>
-        <p:spPr>
-          <a:xfrm>
-            <a:off x="685800" y="502920"/>
-            <a:ext cx="10817352" cy="594360"/>
-          </a:xfrm>
-          <a:prstGeom prst="rect">
-            <a:avLst/>
-          </a:prstGeom>
-          <a:noFill/>
-        </p:spPr>
-        <p:txBody>
-          <a:bodyPr wrap="square">
-            <a:spAutoFit/>
-          </a:bodyPr>
-          <a:lstStyle/>
-          <a:p>
-            <a:pPr algn="l"/>
-            <a:r>
-              <a:rPr sz="2000" b="1" i="0">
-                <a:solidFill>
-                  <a:srgbClr val="1F2C56"/>
-                </a:solidFill>
-                <a:latin typeface="Arial"/>
-              </a:rPr>
-              <a:t>Verbundpartner-Matrix</a:t>
-            </a:r>
+              <a:t>M13  ·  INHALT</a:t>
+            </a:r>
+          </a:p>
+        </p:txBody>
+      </p:sp>
+      <p:sp>
+        <p:nvSpPr>
+          <p:cNvPr id="5" name="Rectangle 4"/>
+          <p:cNvSpPr/>
+          <p:nvPr/>
+        </p:nvSpPr>
+        <p:spPr>
+          <a:xfrm>
+            <a:off x="0" y="1234440"/>
+            <a:ext cx="12188952" cy="12700"/>
+          </a:xfrm>
+          <a:prstGeom prst="rect">
+            <a:avLst/>
+          </a:prstGeom>
+          <a:solidFill>
+            <a:srgbClr val="D8DFE4"/>
+          </a:solidFill>
+          <a:ln>
+            <a:noFill/>
+          </a:ln>
+        </p:spPr>
+        <p:style>
+          <a:lnRef idx="1">
+            <a:schemeClr val="accent1"/>
+          </a:lnRef>
+          <a:fillRef idx="3">
+            <a:schemeClr val="accent1"/>
+          </a:fillRef>
+          <a:effectRef idx="2">
+            <a:schemeClr val="accent1"/>
+          </a:effectRef>
+          <a:fontRef idx="minor">
+            <a:schemeClr val="lt1"/>
+          </a:fontRef>
+        </p:style>
+        <p:txBody>
+          <a:bodyPr rtlCol="0" anchor="ctr"/>
+          <a:lstStyle/>
+          <a:p>
+            <a:pPr algn="ctr"/>
           </a:p>
         </p:txBody>
       </p:sp>
@@ -6882,8 +6314,8 @@
         </p:nvSpPr>
         <p:spPr>
           <a:xfrm>
-            <a:off x="685800" y="1143000"/>
-            <a:ext cx="10817352" cy="25400"/>
+            <a:off x="685800" y="502920"/>
+            <a:ext cx="36576" cy="658368"/>
           </a:xfrm>
           <a:prstGeom prst="rect">
             <a:avLst/>
@@ -6917,33 +6349,105 @@
           </a:p>
         </p:txBody>
       </p:sp>
-      <p:pic>
-        <p:nvPicPr>
-          <p:cNvPr id="7" name="Picture 6" descr="image.png"/>
-          <p:cNvPicPr>
-            <a:picLocks noChangeAspect="1"/>
-          </p:cNvPicPr>
-          <p:nvPr/>
-        </p:nvPicPr>
-        <p:blipFill>
-          <a:blip r:embed="rId2"/>
-          <a:stretch>
-            <a:fillRect/>
-          </a:stretch>
-        </p:blipFill>
-        <p:spPr>
-          <a:xfrm>
-            <a:off x="2433486" y="1325880"/>
-            <a:ext cx="7321979" cy="4937760"/>
-          </a:xfrm>
-          <a:prstGeom prst="rect">
-            <a:avLst/>
-          </a:prstGeom>
-        </p:spPr>
-      </p:pic>
-      <p:sp>
-        <p:nvSpPr>
-          <p:cNvPr id="8" name="Rectangle 7"/>
+      <p:sp>
+        <p:nvSpPr>
+          <p:cNvPr id="7" name="TextBox 6"/>
+          <p:cNvSpPr txBox="1"/>
+          <p:nvPr/>
+        </p:nvSpPr>
+        <p:spPr>
+          <a:xfrm>
+            <a:off x="813816" y="502920"/>
+            <a:ext cx="10634472" cy="685800"/>
+          </a:xfrm>
+          <a:prstGeom prst="rect">
+            <a:avLst/>
+          </a:prstGeom>
+          <a:noFill/>
+        </p:spPr>
+        <p:txBody>
+          <a:bodyPr wrap="square">
+            <a:spAutoFit/>
+          </a:bodyPr>
+          <a:lstStyle/>
+          <a:p>
+            <a:pPr algn="l"/>
+            <a:r>
+              <a:rPr sz="2400" b="1" i="0">
+                <a:solidFill>
+                  <a:srgbClr val="1F2C56"/>
+                </a:solidFill>
+                <a:latin typeface="Arial"/>
+              </a:rPr>
+              <a:t>Prinzip dieses Moduls</a:t>
+            </a:r>
+          </a:p>
+        </p:txBody>
+      </p:sp>
+      <p:sp>
+        <p:nvSpPr>
+          <p:cNvPr id="8" name="TextBox 7"/>
+          <p:cNvSpPr txBox="1"/>
+          <p:nvPr/>
+        </p:nvSpPr>
+        <p:spPr>
+          <a:xfrm>
+            <a:off x="685800" y="1417320"/>
+            <a:ext cx="10817352" cy="4892040"/>
+          </a:xfrm>
+          <a:prstGeom prst="rect">
+            <a:avLst/>
+          </a:prstGeom>
+          <a:noFill/>
+        </p:spPr>
+        <p:txBody>
+          <a:bodyPr wrap="square" anchor="ctr">
+            <a:spAutoFit/>
+          </a:bodyPr>
+          <a:lstStyle/>
+          <a:p>
+            <a:pPr marL="177800" indent="-177800">
+              <a:spcBef>
+                <a:spcPts val="600"/>
+              </a:spcBef>
+              <a:spcAft>
+                <a:spcPts val="200"/>
+              </a:spcAft>
+            </a:pPr>
+            <a:r>
+              <a:rPr sz="1200" i="1">
+                <a:solidFill>
+                  <a:srgbClr val="3D5466"/>
+                </a:solidFill>
+                <a:latin typeface="Arial"/>
+              </a:rPr>
+              <a:t>→  Cross-Selling beginnt beim Bedarf des Kunden, nicht bei der Produktliste der Bank.</a:t>
+            </a:r>
+          </a:p>
+          <a:p>
+            <a:pPr marL="190500" indent="-190500">
+              <a:spcBef>
+                <a:spcPts val="400"/>
+              </a:spcBef>
+              <a:spcAft>
+                <a:spcPts val="200"/>
+              </a:spcAft>
+            </a:pPr>
+            <a:r>
+              <a:rPr sz="1300">
+                <a:solidFill>
+                  <a:srgbClr val="3D5466"/>
+                </a:solidFill>
+                <a:latin typeface="Arial"/>
+              </a:rPr>
+              <a:t>▸  Bedarfsorientiertes Cross-Selling (Pull) bindet und bringt Ertrag; Produkte drücken (Push) verbrennt Vertrauen.</a:t>
+            </a:r>
+          </a:p>
+        </p:txBody>
+      </p:sp>
+      <p:sp>
+        <p:nvSpPr>
+          <p:cNvPr id="9" name="Rectangle 8"/>
           <p:cNvSpPr/>
           <p:nvPr/>
         </p:nvSpPr>
@@ -6986,7 +6490,7 @@
       </p:sp>
       <p:sp>
         <p:nvSpPr>
-          <p:cNvPr id="9" name="TextBox 8"/>
+          <p:cNvPr id="10" name="TextBox 9"/>
           <p:cNvSpPr txBox="1"/>
           <p:nvPr/>
         </p:nvSpPr>
@@ -7015,41 +6519,6 @@
                 <a:latin typeface="Consolas"/>
               </a:rPr>
               <a:t>FKB Campus  ·  M13</a:t>
-            </a:r>
-          </a:p>
-        </p:txBody>
-      </p:sp>
-      <p:sp>
-        <p:nvSpPr>
-          <p:cNvPr id="10" name="TextBox 9"/>
-          <p:cNvSpPr txBox="1"/>
-          <p:nvPr/>
-        </p:nvSpPr>
-        <p:spPr>
-          <a:xfrm>
-            <a:off x="7176211" y="6583680"/>
-            <a:ext cx="4326940" cy="256032"/>
-          </a:xfrm>
-          <a:prstGeom prst="rect">
-            <a:avLst/>
-          </a:prstGeom>
-          <a:noFill/>
-        </p:spPr>
-        <p:txBody>
-          <a:bodyPr wrap="none">
-            <a:spAutoFit/>
-          </a:bodyPr>
-          <a:lstStyle/>
-          <a:p>
-            <a:pPr algn="r"/>
-            <a:r>
-              <a:rPr sz="700">
-                <a:solidFill>
-                  <a:srgbClr val="A0B4D2"/>
-                </a:solidFill>
-                <a:latin typeface="Consolas"/>
-              </a:rPr>
-              <a:t>Schaubild</a:t>
             </a:r>
           </a:p>
         </p:txBody>
@@ -7309,7 +6778,7 @@
                 </a:solidFill>
                 <a:latin typeface="Arial"/>
               </a:rPr>
-              <a:t>AB-1: Wallet-Share-Analyse</a:t>
+              <a:t>Reflexion und Selbstcheck</a:t>
             </a:r>
           </a:p>
         </p:txBody>
@@ -7351,7 +6820,45 @@
                 </a:solidFill>
                 <a:latin typeface="Arial"/>
               </a:rPr>
-              <a:t>▸  Meine Top-2 Cross-Selling-Hypothesen für diesen Kunden:</a:t>
+              <a:t>▸  Bei welchem Bestandskunden ist Ihre Beziehung „flach" – viel Kredit, kein Verbund?</a:t>
+            </a:r>
+          </a:p>
+          <a:p>
+            <a:pPr marL="190500" indent="-190500">
+              <a:spcBef>
+                <a:spcPts val="400"/>
+              </a:spcBef>
+              <a:spcAft>
+                <a:spcPts val="200"/>
+              </a:spcAft>
+            </a:pPr>
+            <a:r>
+              <a:rPr sz="1300">
+                <a:solidFill>
+                  <a:srgbClr val="3D5466"/>
+                </a:solidFill>
+                <a:latin typeface="Arial"/>
+              </a:rPr>
+              <a:t>▸  Welche ereignisbasierte Cross-Selling-Chance haben Sie zuletzt übersehen?</a:t>
+            </a:r>
+          </a:p>
+          <a:p>
+            <a:pPr marL="190500" indent="-190500">
+              <a:spcBef>
+                <a:spcPts val="400"/>
+              </a:spcBef>
+              <a:spcAft>
+                <a:spcPts val="200"/>
+              </a:spcAft>
+            </a:pPr>
+            <a:r>
+              <a:rPr sz="1300">
+                <a:solidFill>
+                  <a:srgbClr val="3D5466"/>
+                </a:solidFill>
+                <a:latin typeface="Arial"/>
+              </a:rPr>
+              <a:t>▸  Wie formulieren Sie eine Bedarfshypothese als Frage statt als Angebot?</a:t>
             </a:r>
           </a:p>
         </p:txBody>
@@ -7430,1359 +6937,6 @@
                 <a:latin typeface="Consolas"/>
               </a:rPr>
               <a:t>FKB Campus  ·  M13</a:t>
-            </a:r>
-          </a:p>
-        </p:txBody>
-      </p:sp>
-    </p:spTree>
-  </p:cSld>
-  <p:clrMapOvr>
-    <a:masterClrMapping/>
-  </p:clrMapOvr>
-</p:sld>
-</file>
-
-<file path=ppt/slides/slide16.xml><?xml version="1.0" encoding="utf-8"?>
-<p:sld xmlns:a="http://schemas.openxmlformats.org/drawingml/2006/main" xmlns:p="http://schemas.openxmlformats.org/presentationml/2006/main" xmlns:r="http://schemas.openxmlformats.org/officeDocument/2006/relationships">
-  <p:cSld>
-    <p:spTree>
-      <p:nvGrpSpPr>
-        <p:cNvPr id="1" name=""/>
-        <p:cNvGrpSpPr/>
-        <p:nvPr/>
-      </p:nvGrpSpPr>
-      <p:grpSpPr/>
-      <p:sp>
-        <p:nvSpPr>
-          <p:cNvPr id="2" name="Rectangle 1"/>
-          <p:cNvSpPr/>
-          <p:nvPr/>
-        </p:nvSpPr>
-        <p:spPr>
-          <a:xfrm>
-            <a:off x="0" y="0"/>
-            <a:ext cx="12188952" cy="6858000"/>
-          </a:xfrm>
-          <a:prstGeom prst="rect">
-            <a:avLst/>
-          </a:prstGeom>
-          <a:solidFill>
-            <a:srgbClr val="FFFFFF"/>
-          </a:solidFill>
-          <a:ln>
-            <a:noFill/>
-          </a:ln>
-        </p:spPr>
-        <p:style>
-          <a:lnRef idx="1">
-            <a:schemeClr val="accent1"/>
-          </a:lnRef>
-          <a:fillRef idx="3">
-            <a:schemeClr val="accent1"/>
-          </a:fillRef>
-          <a:effectRef idx="2">
-            <a:schemeClr val="accent1"/>
-          </a:effectRef>
-          <a:fontRef idx="minor">
-            <a:schemeClr val="lt1"/>
-          </a:fontRef>
-        </p:style>
-        <p:txBody>
-          <a:bodyPr rtlCol="0" anchor="ctr"/>
-          <a:lstStyle/>
-          <a:p>
-            <a:pPr algn="ctr"/>
-          </a:p>
-        </p:txBody>
-      </p:sp>
-      <p:sp>
-        <p:nvSpPr>
-          <p:cNvPr id="3" name="Rectangle 2"/>
-          <p:cNvSpPr/>
-          <p:nvPr/>
-        </p:nvSpPr>
-        <p:spPr>
-          <a:xfrm>
-            <a:off x="0" y="0"/>
-            <a:ext cx="12188952" cy="50292"/>
-          </a:xfrm>
-          <a:prstGeom prst="rect">
-            <a:avLst/>
-          </a:prstGeom>
-          <a:solidFill>
-            <a:srgbClr val="1F2C56"/>
-          </a:solidFill>
-          <a:ln>
-            <a:noFill/>
-          </a:ln>
-        </p:spPr>
-        <p:style>
-          <a:lnRef idx="1">
-            <a:schemeClr val="accent1"/>
-          </a:lnRef>
-          <a:fillRef idx="3">
-            <a:schemeClr val="accent1"/>
-          </a:fillRef>
-          <a:effectRef idx="2">
-            <a:schemeClr val="accent1"/>
-          </a:effectRef>
-          <a:fontRef idx="minor">
-            <a:schemeClr val="lt1"/>
-          </a:fontRef>
-        </p:style>
-        <p:txBody>
-          <a:bodyPr rtlCol="0" anchor="ctr"/>
-          <a:lstStyle/>
-          <a:p>
-            <a:pPr algn="ctr"/>
-          </a:p>
-        </p:txBody>
-      </p:sp>
-      <p:sp>
-        <p:nvSpPr>
-          <p:cNvPr id="4" name="TextBox 3"/>
-          <p:cNvSpPr txBox="1"/>
-          <p:nvPr/>
-        </p:nvSpPr>
-        <p:spPr>
-          <a:xfrm>
-            <a:off x="685800" y="109728"/>
-            <a:ext cx="10817352" cy="228600"/>
-          </a:xfrm>
-          <a:prstGeom prst="rect">
-            <a:avLst/>
-          </a:prstGeom>
-          <a:noFill/>
-        </p:spPr>
-        <p:txBody>
-          <a:bodyPr wrap="none">
-            <a:spAutoFit/>
-          </a:bodyPr>
-          <a:lstStyle/>
-          <a:p>
-            <a:pPr algn="l"/>
-            <a:r>
-              <a:rPr sz="750">
-                <a:solidFill>
-                  <a:srgbClr val="78808C"/>
-                </a:solidFill>
-                <a:latin typeface="Consolas"/>
-              </a:rPr>
-              <a:t>M13  ·  ÜBERSICHT</a:t>
-            </a:r>
-          </a:p>
-        </p:txBody>
-      </p:sp>
-      <p:sp>
-        <p:nvSpPr>
-          <p:cNvPr id="5" name="TextBox 4"/>
-          <p:cNvSpPr txBox="1"/>
-          <p:nvPr/>
-        </p:nvSpPr>
-        <p:spPr>
-          <a:xfrm>
-            <a:off x="685800" y="502920"/>
-            <a:ext cx="10817352" cy="594360"/>
-          </a:xfrm>
-          <a:prstGeom prst="rect">
-            <a:avLst/>
-          </a:prstGeom>
-          <a:noFill/>
-        </p:spPr>
-        <p:txBody>
-          <a:bodyPr wrap="square">
-            <a:spAutoFit/>
-          </a:bodyPr>
-          <a:lstStyle/>
-          <a:p>
-            <a:pPr algn="l"/>
-            <a:r>
-              <a:rPr sz="2000" b="1" i="0">
-                <a:solidFill>
-                  <a:srgbClr val="1F2C56"/>
-                </a:solidFill>
-                <a:latin typeface="Arial"/>
-              </a:rPr>
-              <a:t>AB-1: Wallet-Share-Analyse</a:t>
-            </a:r>
-          </a:p>
-        </p:txBody>
-      </p:sp>
-      <p:sp>
-        <p:nvSpPr>
-          <p:cNvPr id="6" name="Rectangle 5"/>
-          <p:cNvSpPr/>
-          <p:nvPr/>
-        </p:nvSpPr>
-        <p:spPr>
-          <a:xfrm>
-            <a:off x="685800" y="1143000"/>
-            <a:ext cx="10817352" cy="25400"/>
-          </a:xfrm>
-          <a:prstGeom prst="rect">
-            <a:avLst/>
-          </a:prstGeom>
-          <a:solidFill>
-            <a:srgbClr val="D9C089"/>
-          </a:solidFill>
-          <a:ln>
-            <a:noFill/>
-          </a:ln>
-        </p:spPr>
-        <p:style>
-          <a:lnRef idx="1">
-            <a:schemeClr val="accent1"/>
-          </a:lnRef>
-          <a:fillRef idx="3">
-            <a:schemeClr val="accent1"/>
-          </a:fillRef>
-          <a:effectRef idx="2">
-            <a:schemeClr val="accent1"/>
-          </a:effectRef>
-          <a:fontRef idx="minor">
-            <a:schemeClr val="lt1"/>
-          </a:fontRef>
-        </p:style>
-        <p:txBody>
-          <a:bodyPr rtlCol="0" anchor="ctr"/>
-          <a:lstStyle/>
-          <a:p>
-            <a:pPr algn="ctr"/>
-          </a:p>
-        </p:txBody>
-      </p:sp>
-      <p:graphicFrame>
-        <p:nvGraphicFramePr>
-          <p:cNvPr id="7" name="Table 6"/>
-          <p:cNvGraphicFramePr>
-            <a:graphicFrameLocks noGrp="1"/>
-          </p:cNvGraphicFramePr>
-          <p:nvPr/>
-        </p:nvGraphicFramePr>
-        <p:xfrm>
-          <a:off x="685800" y="1417320"/>
-          <a:ext cx="10817352" cy="2688336"/>
-        </p:xfrm>
-        <a:graphic>
-          <a:graphicData uri="http://schemas.openxmlformats.org/drawingml/2006/table">
-            <a:tbl>
-              <a:tblPr firstRow="1" bandRow="1">
-                <a:tableStyleId>{5C22544A-7EE6-4342-B048-85BDC9FD1C3A}</a:tableStyleId>
-              </a:tblPr>
-              <a:tblGrid>
-                <a:gridCol w="2163470"/>
-                <a:gridCol w="2163470"/>
-                <a:gridCol w="2163470"/>
-                <a:gridCol w="2163470"/>
-                <a:gridCol w="2163472"/>
-              </a:tblGrid>
-              <a:tr h="384048">
-                <a:tc>
-                  <a:txBody>
-                    <a:bodyPr/>
-                    <a:lstStyle/>
-                    <a:p>
-                      <a:r>
-                        <a:rPr sz="1100" b="1">
-                          <a:solidFill>
-                            <a:srgbClr val="FFFFFF"/>
-                          </a:solidFill>
-                          <a:latin typeface="Arial"/>
-                        </a:rPr>
-                        <a:t>Dimension</a:t>
-                      </a:r>
-                    </a:p>
-                  </a:txBody>
-                  <a:tcPr>
-                    <a:solidFill>
-                      <a:srgbClr val="1F2C56"/>
-                    </a:solidFill>
-                  </a:tcPr>
-                </a:tc>
-                <a:tc>
-                  <a:txBody>
-                    <a:bodyPr/>
-                    <a:lstStyle/>
-                    <a:p>
-                      <a:r>
-                        <a:rPr sz="1100" b="1">
-                          <a:solidFill>
-                            <a:srgbClr val="FFFFFF"/>
-                          </a:solidFill>
-                          <a:latin typeface="Arial"/>
-                        </a:rPr>
-                        <a:t>Aktueller Stand (uns bekannt)</a:t>
-                      </a:r>
-                    </a:p>
-                  </a:txBody>
-                  <a:tcPr>
-                    <a:solidFill>
-                      <a:srgbClr val="1F2C56"/>
-                    </a:solidFill>
-                  </a:tcPr>
-                </a:tc>
-                <a:tc>
-                  <a:txBody>
-                    <a:bodyPr/>
-                    <a:lstStyle/>
-                    <a:p>
-                      <a:r>
-                        <a:rPr sz="1100" b="1">
-                          <a:solidFill>
-                            <a:srgbClr val="FFFFFF"/>
-                          </a:solidFill>
-                          <a:latin typeface="Arial"/>
-                        </a:rPr>
-                        <a:t>Schätzung Gesamtbedarf</a:t>
-                      </a:r>
-                    </a:p>
-                  </a:txBody>
-                  <a:tcPr>
-                    <a:solidFill>
-                      <a:srgbClr val="1F2C56"/>
-                    </a:solidFill>
-                  </a:tcPr>
-                </a:tc>
-                <a:tc>
-                  <a:txBody>
-                    <a:bodyPr/>
-                    <a:lstStyle/>
-                    <a:p>
-                      <a:r>
-                        <a:rPr sz="1100" b="1">
-                          <a:solidFill>
-                            <a:srgbClr val="FFFFFF"/>
-                          </a:solidFill>
-                          <a:latin typeface="Arial"/>
-                        </a:rPr>
-                        <a:t>Wallet-Share (%)</a:t>
-                      </a:r>
-                    </a:p>
-                  </a:txBody>
-                  <a:tcPr>
-                    <a:solidFill>
-                      <a:srgbClr val="1F2C56"/>
-                    </a:solidFill>
-                  </a:tcPr>
-                </a:tc>
-                <a:tc>
-                  <a:txBody>
-                    <a:bodyPr/>
-                    <a:lstStyle/>
-                    <a:p>
-                      <a:r>
-                        <a:rPr sz="1100" b="1">
-                          <a:solidFill>
-                            <a:srgbClr val="FFFFFF"/>
-                          </a:solidFill>
-                          <a:latin typeface="Arial"/>
-                        </a:rPr>
-                        <a:t>Cross-Selling-Potenzial</a:t>
-                      </a:r>
-                    </a:p>
-                  </a:txBody>
-                  <a:tcPr>
-                    <a:solidFill>
-                      <a:srgbClr val="1F2C56"/>
-                    </a:solidFill>
-                  </a:tcPr>
-                </a:tc>
-              </a:tr>
-              <a:tr h="384048">
-                <a:tc>
-                  <a:txBody>
-                    <a:bodyPr/>
-                    <a:lstStyle/>
-                    <a:p>
-                      <a:r>
-                        <a:rPr sz="1050">
-                          <a:solidFill>
-                            <a:srgbClr val="3D5466"/>
-                          </a:solidFill>
-                          <a:latin typeface="Arial"/>
-                        </a:rPr>
-                        <a:t>Finanzierung</a:t>
-                      </a:r>
-                    </a:p>
-                  </a:txBody>
-                  <a:tcPr/>
-                </a:tc>
-                <a:tc>
-                  <a:txBody>
-                    <a:bodyPr/>
-                    <a:lstStyle/>
-                    <a:p/>
-                  </a:txBody>
-                  <a:tcPr/>
-                </a:tc>
-                <a:tc>
-                  <a:txBody>
-                    <a:bodyPr/>
-                    <a:lstStyle/>
-                    <a:p/>
-                  </a:txBody>
-                  <a:tcPr/>
-                </a:tc>
-                <a:tc>
-                  <a:txBody>
-                    <a:bodyPr/>
-                    <a:lstStyle/>
-                    <a:p/>
-                  </a:txBody>
-                  <a:tcPr/>
-                </a:tc>
-                <a:tc>
-                  <a:txBody>
-                    <a:bodyPr/>
-                    <a:lstStyle/>
-                    <a:p/>
-                  </a:txBody>
-                  <a:tcPr/>
-                </a:tc>
-              </a:tr>
-              <a:tr h="384048">
-                <a:tc>
-                  <a:txBody>
-                    <a:bodyPr/>
-                    <a:lstStyle/>
-                    <a:p>
-                      <a:r>
-                        <a:rPr sz="1050">
-                          <a:solidFill>
-                            <a:srgbClr val="3D5466"/>
-                          </a:solidFill>
-                          <a:latin typeface="Arial"/>
-                        </a:rPr>
-                        <a:t>Absicherung</a:t>
-                      </a:r>
-                    </a:p>
-                  </a:txBody>
-                  <a:tcPr/>
-                </a:tc>
-                <a:tc>
-                  <a:txBody>
-                    <a:bodyPr/>
-                    <a:lstStyle/>
-                    <a:p/>
-                  </a:txBody>
-                  <a:tcPr/>
-                </a:tc>
-                <a:tc>
-                  <a:txBody>
-                    <a:bodyPr/>
-                    <a:lstStyle/>
-                    <a:p/>
-                  </a:txBody>
-                  <a:tcPr/>
-                </a:tc>
-                <a:tc>
-                  <a:txBody>
-                    <a:bodyPr/>
-                    <a:lstStyle/>
-                    <a:p/>
-                  </a:txBody>
-                  <a:tcPr/>
-                </a:tc>
-                <a:tc>
-                  <a:txBody>
-                    <a:bodyPr/>
-                    <a:lstStyle/>
-                    <a:p/>
-                  </a:txBody>
-                  <a:tcPr/>
-                </a:tc>
-              </a:tr>
-              <a:tr h="384048">
-                <a:tc>
-                  <a:txBody>
-                    <a:bodyPr/>
-                    <a:lstStyle/>
-                    <a:p>
-                      <a:r>
-                        <a:rPr sz="1050">
-                          <a:solidFill>
-                            <a:srgbClr val="3D5466"/>
-                          </a:solidFill>
-                          <a:latin typeface="Arial"/>
-                        </a:rPr>
-                        <a:t>Kapitalanlage</a:t>
-                      </a:r>
-                    </a:p>
-                  </a:txBody>
-                  <a:tcPr/>
-                </a:tc>
-                <a:tc>
-                  <a:txBody>
-                    <a:bodyPr/>
-                    <a:lstStyle/>
-                    <a:p/>
-                  </a:txBody>
-                  <a:tcPr/>
-                </a:tc>
-                <a:tc>
-                  <a:txBody>
-                    <a:bodyPr/>
-                    <a:lstStyle/>
-                    <a:p/>
-                  </a:txBody>
-                  <a:tcPr/>
-                </a:tc>
-                <a:tc>
-                  <a:txBody>
-                    <a:bodyPr/>
-                    <a:lstStyle/>
-                    <a:p/>
-                  </a:txBody>
-                  <a:tcPr/>
-                </a:tc>
-                <a:tc>
-                  <a:txBody>
-                    <a:bodyPr/>
-                    <a:lstStyle/>
-                    <a:p/>
-                  </a:txBody>
-                  <a:tcPr/>
-                </a:tc>
-              </a:tr>
-              <a:tr h="384048">
-                <a:tc>
-                  <a:txBody>
-                    <a:bodyPr/>
-                    <a:lstStyle/>
-                    <a:p>
-                      <a:r>
-                        <a:rPr sz="1050">
-                          <a:solidFill>
-                            <a:srgbClr val="3D5466"/>
-                          </a:solidFill>
-                          <a:latin typeface="Arial"/>
-                        </a:rPr>
-                        <a:t>Zahlungsverkehr</a:t>
-                      </a:r>
-                    </a:p>
-                  </a:txBody>
-                  <a:tcPr/>
-                </a:tc>
-                <a:tc>
-                  <a:txBody>
-                    <a:bodyPr/>
-                    <a:lstStyle/>
-                    <a:p/>
-                  </a:txBody>
-                  <a:tcPr/>
-                </a:tc>
-                <a:tc>
-                  <a:txBody>
-                    <a:bodyPr/>
-                    <a:lstStyle/>
-                    <a:p/>
-                  </a:txBody>
-                  <a:tcPr/>
-                </a:tc>
-                <a:tc>
-                  <a:txBody>
-                    <a:bodyPr/>
-                    <a:lstStyle/>
-                    <a:p/>
-                  </a:txBody>
-                  <a:tcPr/>
-                </a:tc>
-                <a:tc>
-                  <a:txBody>
-                    <a:bodyPr/>
-                    <a:lstStyle/>
-                    <a:p/>
-                  </a:txBody>
-                  <a:tcPr/>
-                </a:tc>
-              </a:tr>
-              <a:tr h="384048">
-                <a:tc>
-                  <a:txBody>
-                    <a:bodyPr/>
-                    <a:lstStyle/>
-                    <a:p>
-                      <a:r>
-                        <a:rPr sz="1050">
-                          <a:solidFill>
-                            <a:srgbClr val="3D5466"/>
-                          </a:solidFill>
-                          <a:latin typeface="Arial"/>
-                        </a:rPr>
-                        <a:t>Privat/Gesellschafter</a:t>
-                      </a:r>
-                    </a:p>
-                  </a:txBody>
-                  <a:tcPr/>
-                </a:tc>
-                <a:tc>
-                  <a:txBody>
-                    <a:bodyPr/>
-                    <a:lstStyle/>
-                    <a:p/>
-                  </a:txBody>
-                  <a:tcPr/>
-                </a:tc>
-                <a:tc>
-                  <a:txBody>
-                    <a:bodyPr/>
-                    <a:lstStyle/>
-                    <a:p/>
-                  </a:txBody>
-                  <a:tcPr/>
-                </a:tc>
-                <a:tc>
-                  <a:txBody>
-                    <a:bodyPr/>
-                    <a:lstStyle/>
-                    <a:p/>
-                  </a:txBody>
-                  <a:tcPr/>
-                </a:tc>
-                <a:tc>
-                  <a:txBody>
-                    <a:bodyPr/>
-                    <a:lstStyle/>
-                    <a:p/>
-                  </a:txBody>
-                  <a:tcPr/>
-                </a:tc>
-              </a:tr>
-              <a:tr h="384048">
-                <a:tc>
-                  <a:txBody>
-                    <a:bodyPr/>
-                    <a:lstStyle/>
-                    <a:p>
-                      <a:r>
-                        <a:rPr sz="1050">
-                          <a:solidFill>
-                            <a:srgbClr val="3D5466"/>
-                          </a:solidFill>
-                          <a:latin typeface="Arial"/>
-                        </a:rPr>
-                        <a:t>Gesamt</a:t>
-                      </a:r>
-                    </a:p>
-                  </a:txBody>
-                  <a:tcPr/>
-                </a:tc>
-                <a:tc>
-                  <a:txBody>
-                    <a:bodyPr/>
-                    <a:lstStyle/>
-                    <a:p/>
-                  </a:txBody>
-                  <a:tcPr/>
-                </a:tc>
-                <a:tc>
-                  <a:txBody>
-                    <a:bodyPr/>
-                    <a:lstStyle/>
-                    <a:p/>
-                  </a:txBody>
-                  <a:tcPr/>
-                </a:tc>
-                <a:tc>
-                  <a:txBody>
-                    <a:bodyPr/>
-                    <a:lstStyle/>
-                    <a:p/>
-                  </a:txBody>
-                  <a:tcPr/>
-                </a:tc>
-                <a:tc>
-                  <a:txBody>
-                    <a:bodyPr/>
-                    <a:lstStyle/>
-                    <a:p/>
-                  </a:txBody>
-                  <a:tcPr/>
-                </a:tc>
-              </a:tr>
-            </a:tbl>
-          </a:graphicData>
-        </a:graphic>
-      </p:graphicFrame>
-      <p:sp>
-        <p:nvSpPr>
-          <p:cNvPr id="8" name="Rectangle 7"/>
-          <p:cNvSpPr/>
-          <p:nvPr/>
-        </p:nvSpPr>
-        <p:spPr>
-          <a:xfrm>
-            <a:off x="0" y="6510528"/>
-            <a:ext cx="12188952" cy="347472"/>
-          </a:xfrm>
-          <a:prstGeom prst="rect">
-            <a:avLst/>
-          </a:prstGeom>
-          <a:solidFill>
-            <a:srgbClr val="0A1937"/>
-          </a:solidFill>
-          <a:ln>
-            <a:noFill/>
-          </a:ln>
-        </p:spPr>
-        <p:style>
-          <a:lnRef idx="1">
-            <a:schemeClr val="accent1"/>
-          </a:lnRef>
-          <a:fillRef idx="3">
-            <a:schemeClr val="accent1"/>
-          </a:fillRef>
-          <a:effectRef idx="2">
-            <a:schemeClr val="accent1"/>
-          </a:effectRef>
-          <a:fontRef idx="minor">
-            <a:schemeClr val="lt1"/>
-          </a:fontRef>
-        </p:style>
-        <p:txBody>
-          <a:bodyPr rtlCol="0" anchor="ctr"/>
-          <a:lstStyle/>
-          <a:p>
-            <a:pPr algn="ctr"/>
-          </a:p>
-        </p:txBody>
-      </p:sp>
-      <p:sp>
-        <p:nvSpPr>
-          <p:cNvPr id="9" name="TextBox 8"/>
-          <p:cNvSpPr txBox="1"/>
-          <p:nvPr/>
-        </p:nvSpPr>
-        <p:spPr>
-          <a:xfrm>
-            <a:off x="685800" y="6583680"/>
-            <a:ext cx="6490411" cy="256032"/>
-          </a:xfrm>
-          <a:prstGeom prst="rect">
-            <a:avLst/>
-          </a:prstGeom>
-          <a:noFill/>
-        </p:spPr>
-        <p:txBody>
-          <a:bodyPr wrap="none">
-            <a:spAutoFit/>
-          </a:bodyPr>
-          <a:lstStyle/>
-          <a:p>
-            <a:pPr algn="l"/>
-            <a:r>
-              <a:rPr sz="700">
-                <a:solidFill>
-                  <a:srgbClr val="A0B4D2"/>
-                </a:solidFill>
-                <a:latin typeface="Consolas"/>
-              </a:rPr>
-              <a:t>FKB Campus  ·  M13</a:t>
-            </a:r>
-          </a:p>
-        </p:txBody>
-      </p:sp>
-      <p:sp>
-        <p:nvSpPr>
-          <p:cNvPr id="10" name="TextBox 9"/>
-          <p:cNvSpPr txBox="1"/>
-          <p:nvPr/>
-        </p:nvSpPr>
-        <p:spPr>
-          <a:xfrm>
-            <a:off x="7176211" y="6583680"/>
-            <a:ext cx="4326940" cy="256032"/>
-          </a:xfrm>
-          <a:prstGeom prst="rect">
-            <a:avLst/>
-          </a:prstGeom>
-          <a:noFill/>
-        </p:spPr>
-        <p:txBody>
-          <a:bodyPr wrap="none">
-            <a:spAutoFit/>
-          </a:bodyPr>
-          <a:lstStyle/>
-          <a:p>
-            <a:pPr algn="r"/>
-            <a:r>
-              <a:rPr sz="700">
-                <a:solidFill>
-                  <a:srgbClr val="A0B4D2"/>
-                </a:solidFill>
-                <a:latin typeface="Consolas"/>
-              </a:rPr>
-              <a:t>Übersicht</a:t>
-            </a:r>
-          </a:p>
-        </p:txBody>
-      </p:sp>
-    </p:spTree>
-  </p:cSld>
-  <p:clrMapOvr>
-    <a:masterClrMapping/>
-  </p:clrMapOvr>
-</p:sld>
-</file>
-
-<file path=ppt/slides/slide17.xml><?xml version="1.0" encoding="utf-8"?>
-<p:sld xmlns:a="http://schemas.openxmlformats.org/drawingml/2006/main" xmlns:p="http://schemas.openxmlformats.org/presentationml/2006/main" xmlns:r="http://schemas.openxmlformats.org/officeDocument/2006/relationships">
-  <p:cSld>
-    <p:spTree>
-      <p:nvGrpSpPr>
-        <p:cNvPr id="1" name=""/>
-        <p:cNvGrpSpPr/>
-        <p:nvPr/>
-      </p:nvGrpSpPr>
-      <p:grpSpPr/>
-      <p:sp>
-        <p:nvSpPr>
-          <p:cNvPr id="2" name="Rectangle 1"/>
-          <p:cNvSpPr/>
-          <p:nvPr/>
-        </p:nvSpPr>
-        <p:spPr>
-          <a:xfrm>
-            <a:off x="0" y="0"/>
-            <a:ext cx="12188952" cy="6858000"/>
-          </a:xfrm>
-          <a:prstGeom prst="rect">
-            <a:avLst/>
-          </a:prstGeom>
-          <a:solidFill>
-            <a:srgbClr val="FFFFFF"/>
-          </a:solidFill>
-          <a:ln>
-            <a:noFill/>
-          </a:ln>
-        </p:spPr>
-        <p:style>
-          <a:lnRef idx="1">
-            <a:schemeClr val="accent1"/>
-          </a:lnRef>
-          <a:fillRef idx="3">
-            <a:schemeClr val="accent1"/>
-          </a:fillRef>
-          <a:effectRef idx="2">
-            <a:schemeClr val="accent1"/>
-          </a:effectRef>
-          <a:fontRef idx="minor">
-            <a:schemeClr val="lt1"/>
-          </a:fontRef>
-        </p:style>
-        <p:txBody>
-          <a:bodyPr rtlCol="0" anchor="ctr"/>
-          <a:lstStyle/>
-          <a:p>
-            <a:pPr algn="ctr"/>
-          </a:p>
-        </p:txBody>
-      </p:sp>
-      <p:sp>
-        <p:nvSpPr>
-          <p:cNvPr id="3" name="Rectangle 2"/>
-          <p:cNvSpPr/>
-          <p:nvPr/>
-        </p:nvSpPr>
-        <p:spPr>
-          <a:xfrm>
-            <a:off x="0" y="0"/>
-            <a:ext cx="12188952" cy="50292"/>
-          </a:xfrm>
-          <a:prstGeom prst="rect">
-            <a:avLst/>
-          </a:prstGeom>
-          <a:solidFill>
-            <a:srgbClr val="1F2C56"/>
-          </a:solidFill>
-          <a:ln>
-            <a:noFill/>
-          </a:ln>
-        </p:spPr>
-        <p:style>
-          <a:lnRef idx="1">
-            <a:schemeClr val="accent1"/>
-          </a:lnRef>
-          <a:fillRef idx="3">
-            <a:schemeClr val="accent1"/>
-          </a:fillRef>
-          <a:effectRef idx="2">
-            <a:schemeClr val="accent1"/>
-          </a:effectRef>
-          <a:fontRef idx="minor">
-            <a:schemeClr val="lt1"/>
-          </a:fontRef>
-        </p:style>
-        <p:txBody>
-          <a:bodyPr rtlCol="0" anchor="ctr"/>
-          <a:lstStyle/>
-          <a:p>
-            <a:pPr algn="ctr"/>
-          </a:p>
-        </p:txBody>
-      </p:sp>
-      <p:sp>
-        <p:nvSpPr>
-          <p:cNvPr id="4" name="TextBox 3"/>
-          <p:cNvSpPr txBox="1"/>
-          <p:nvPr/>
-        </p:nvSpPr>
-        <p:spPr>
-          <a:xfrm>
-            <a:off x="685800" y="109728"/>
-            <a:ext cx="10817352" cy="228600"/>
-          </a:xfrm>
-          <a:prstGeom prst="rect">
-            <a:avLst/>
-          </a:prstGeom>
-          <a:noFill/>
-        </p:spPr>
-        <p:txBody>
-          <a:bodyPr wrap="none">
-            <a:spAutoFit/>
-          </a:bodyPr>
-          <a:lstStyle/>
-          <a:p>
-            <a:pPr algn="l"/>
-            <a:r>
-              <a:rPr sz="750">
-                <a:solidFill>
-                  <a:srgbClr val="78808C"/>
-                </a:solidFill>
-                <a:latin typeface="Consolas"/>
-              </a:rPr>
-              <a:t>M13  ·  ÜBERSICHT</a:t>
-            </a:r>
-          </a:p>
-        </p:txBody>
-      </p:sp>
-      <p:sp>
-        <p:nvSpPr>
-          <p:cNvPr id="5" name="TextBox 4"/>
-          <p:cNvSpPr txBox="1"/>
-          <p:nvPr/>
-        </p:nvSpPr>
-        <p:spPr>
-          <a:xfrm>
-            <a:off x="685800" y="502920"/>
-            <a:ext cx="10817352" cy="594360"/>
-          </a:xfrm>
-          <a:prstGeom prst="rect">
-            <a:avLst/>
-          </a:prstGeom>
-          <a:noFill/>
-        </p:spPr>
-        <p:txBody>
-          <a:bodyPr wrap="square">
-            <a:spAutoFit/>
-          </a:bodyPr>
-          <a:lstStyle/>
-          <a:p>
-            <a:pPr algn="l"/>
-            <a:r>
-              <a:rPr sz="2000" b="1" i="0">
-                <a:solidFill>
-                  <a:srgbClr val="1F2C56"/>
-                </a:solidFill>
-                <a:latin typeface="Arial"/>
-              </a:rPr>
-              <a:t>AB-2: Cross-Selling-Gesprächsvorbereitung</a:t>
-            </a:r>
-          </a:p>
-        </p:txBody>
-      </p:sp>
-      <p:sp>
-        <p:nvSpPr>
-          <p:cNvPr id="6" name="Rectangle 5"/>
-          <p:cNvSpPr/>
-          <p:nvPr/>
-        </p:nvSpPr>
-        <p:spPr>
-          <a:xfrm>
-            <a:off x="685800" y="1143000"/>
-            <a:ext cx="10817352" cy="25400"/>
-          </a:xfrm>
-          <a:prstGeom prst="rect">
-            <a:avLst/>
-          </a:prstGeom>
-          <a:solidFill>
-            <a:srgbClr val="D9C089"/>
-          </a:solidFill>
-          <a:ln>
-            <a:noFill/>
-          </a:ln>
-        </p:spPr>
-        <p:style>
-          <a:lnRef idx="1">
-            <a:schemeClr val="accent1"/>
-          </a:lnRef>
-          <a:fillRef idx="3">
-            <a:schemeClr val="accent1"/>
-          </a:fillRef>
-          <a:effectRef idx="2">
-            <a:schemeClr val="accent1"/>
-          </a:effectRef>
-          <a:fontRef idx="minor">
-            <a:schemeClr val="lt1"/>
-          </a:fontRef>
-        </p:style>
-        <p:txBody>
-          <a:bodyPr rtlCol="0" anchor="ctr"/>
-          <a:lstStyle/>
-          <a:p>
-            <a:pPr algn="ctr"/>
-          </a:p>
-        </p:txBody>
-      </p:sp>
-      <p:graphicFrame>
-        <p:nvGraphicFramePr>
-          <p:cNvPr id="7" name="Table 6"/>
-          <p:cNvGraphicFramePr>
-            <a:graphicFrameLocks noGrp="1"/>
-          </p:cNvGraphicFramePr>
-          <p:nvPr/>
-        </p:nvGraphicFramePr>
-        <p:xfrm>
-          <a:off x="685800" y="1417320"/>
-          <a:ext cx="10817352" cy="2688336"/>
-        </p:xfrm>
-        <a:graphic>
-          <a:graphicData uri="http://schemas.openxmlformats.org/drawingml/2006/table">
-            <a:tbl>
-              <a:tblPr firstRow="1" bandRow="1">
-                <a:tableStyleId>{5C22544A-7EE6-4342-B048-85BDC9FD1C3A}</a:tableStyleId>
-              </a:tblPr>
-              <a:tblGrid>
-                <a:gridCol w="5408676"/>
-                <a:gridCol w="5408676"/>
-              </a:tblGrid>
-              <a:tr h="384048">
-                <a:tc>
-                  <a:txBody>
-                    <a:bodyPr/>
-                    <a:lstStyle/>
-                    <a:p>
-                      <a:r>
-                        <a:rPr sz="1100" b="1">
-                          <a:solidFill>
-                            <a:srgbClr val="FFFFFF"/>
-                          </a:solidFill>
-                          <a:latin typeface="Arial"/>
-                        </a:rPr>
-                        <a:t>Schritt</a:t>
-                      </a:r>
-                    </a:p>
-                  </a:txBody>
-                  <a:tcPr>
-                    <a:solidFill>
-                      <a:srgbClr val="1F2C56"/>
-                    </a:solidFill>
-                  </a:tcPr>
-                </a:tc>
-                <a:tc>
-                  <a:txBody>
-                    <a:bodyPr/>
-                    <a:lstStyle/>
-                    <a:p>
-                      <a:r>
-                        <a:rPr sz="1100" b="1">
-                          <a:solidFill>
-                            <a:srgbClr val="FFFFFF"/>
-                          </a:solidFill>
-                          <a:latin typeface="Arial"/>
-                        </a:rPr>
-                        <a:t>Meine Vorbereitung</a:t>
-                      </a:r>
-                    </a:p>
-                  </a:txBody>
-                  <a:tcPr>
-                    <a:solidFill>
-                      <a:srgbClr val="1F2C56"/>
-                    </a:solidFill>
-                  </a:tcPr>
-                </a:tc>
-              </a:tr>
-              <a:tr h="384048">
-                <a:tc>
-                  <a:txBody>
-                    <a:bodyPr/>
-                    <a:lstStyle/>
-                    <a:p>
-                      <a:r>
-                        <a:rPr sz="1050">
-                          <a:solidFill>
-                            <a:srgbClr val="3D5466"/>
-                          </a:solidFill>
-                          <a:latin typeface="Arial"/>
-                        </a:rPr>
-                        <a:t>Situationsfrage</a:t>
-                      </a:r>
-                    </a:p>
-                  </a:txBody>
-                  <a:tcPr/>
-                </a:tc>
-                <a:tc>
-                  <a:txBody>
-                    <a:bodyPr/>
-                    <a:lstStyle/>
-                    <a:p/>
-                  </a:txBody>
-                  <a:tcPr/>
-                </a:tc>
-              </a:tr>
-              <a:tr h="384048">
-                <a:tc>
-                  <a:txBody>
-                    <a:bodyPr/>
-                    <a:lstStyle/>
-                    <a:p>
-                      <a:r>
-                        <a:rPr sz="1050">
-                          <a:solidFill>
-                            <a:srgbClr val="3D5466"/>
-                          </a:solidFill>
-                          <a:latin typeface="Arial"/>
-                        </a:rPr>
-                        <a:t>Problemfrage</a:t>
-                      </a:r>
-                    </a:p>
-                  </a:txBody>
-                  <a:tcPr/>
-                </a:tc>
-                <a:tc>
-                  <a:txBody>
-                    <a:bodyPr/>
-                    <a:lstStyle/>
-                    <a:p/>
-                  </a:txBody>
-                  <a:tcPr/>
-                </a:tc>
-              </a:tr>
-              <a:tr h="384048">
-                <a:tc>
-                  <a:txBody>
-                    <a:bodyPr/>
-                    <a:lstStyle/>
-                    <a:p>
-                      <a:r>
-                        <a:rPr sz="1050">
-                          <a:solidFill>
-                            <a:srgbClr val="3D5466"/>
-                          </a:solidFill>
-                          <a:latin typeface="Arial"/>
-                        </a:rPr>
-                        <a:t>Implikationsfrage</a:t>
-                      </a:r>
-                    </a:p>
-                  </a:txBody>
-                  <a:tcPr/>
-                </a:tc>
-                <a:tc>
-                  <a:txBody>
-                    <a:bodyPr/>
-                    <a:lstStyle/>
-                    <a:p/>
-                  </a:txBody>
-                  <a:tcPr/>
-                </a:tc>
-              </a:tr>
-              <a:tr h="384048">
-                <a:tc>
-                  <a:txBody>
-                    <a:bodyPr/>
-                    <a:lstStyle/>
-                    <a:p>
-                      <a:r>
-                        <a:rPr sz="1050">
-                          <a:solidFill>
-                            <a:srgbClr val="3D5466"/>
-                          </a:solidFill>
-                          <a:latin typeface="Arial"/>
-                        </a:rPr>
-                        <a:t>Nutzenfrage</a:t>
-                      </a:r>
-                    </a:p>
-                  </a:txBody>
-                  <a:tcPr/>
-                </a:tc>
-                <a:tc>
-                  <a:txBody>
-                    <a:bodyPr/>
-                    <a:lstStyle/>
-                    <a:p/>
-                  </a:txBody>
-                  <a:tcPr/>
-                </a:tc>
-              </a:tr>
-              <a:tr h="384048">
-                <a:tc>
-                  <a:txBody>
-                    <a:bodyPr/>
-                    <a:lstStyle/>
-                    <a:p>
-                      <a:r>
-                        <a:rPr sz="1050">
-                          <a:solidFill>
-                            <a:srgbClr val="3D5466"/>
-                          </a:solidFill>
-                          <a:latin typeface="Arial"/>
-                        </a:rPr>
-                        <a:t>Verbundpartner / Lösung</a:t>
-                      </a:r>
-                    </a:p>
-                  </a:txBody>
-                  <a:tcPr/>
-                </a:tc>
-                <a:tc>
-                  <a:txBody>
-                    <a:bodyPr/>
-                    <a:lstStyle/>
-                    <a:p/>
-                  </a:txBody>
-                  <a:tcPr/>
-                </a:tc>
-              </a:tr>
-              <a:tr h="384048">
-                <a:tc>
-                  <a:txBody>
-                    <a:bodyPr/>
-                    <a:lstStyle/>
-                    <a:p>
-                      <a:r>
-                        <a:rPr sz="1050">
-                          <a:solidFill>
-                            <a:srgbClr val="3D5466"/>
-                          </a:solidFill>
-                          <a:latin typeface="Arial"/>
-                        </a:rPr>
-                        <a:t>Dokumentation in agree</a:t>
-                      </a:r>
-                    </a:p>
-                  </a:txBody>
-                  <a:tcPr/>
-                </a:tc>
-                <a:tc>
-                  <a:txBody>
-                    <a:bodyPr/>
-                    <a:lstStyle/>
-                    <a:p/>
-                  </a:txBody>
-                  <a:tcPr/>
-                </a:tc>
-              </a:tr>
-            </a:tbl>
-          </a:graphicData>
-        </a:graphic>
-      </p:graphicFrame>
-      <p:sp>
-        <p:nvSpPr>
-          <p:cNvPr id="8" name="Rectangle 7"/>
-          <p:cNvSpPr/>
-          <p:nvPr/>
-        </p:nvSpPr>
-        <p:spPr>
-          <a:xfrm>
-            <a:off x="0" y="6510528"/>
-            <a:ext cx="12188952" cy="347472"/>
-          </a:xfrm>
-          <a:prstGeom prst="rect">
-            <a:avLst/>
-          </a:prstGeom>
-          <a:solidFill>
-            <a:srgbClr val="0A1937"/>
-          </a:solidFill>
-          <a:ln>
-            <a:noFill/>
-          </a:ln>
-        </p:spPr>
-        <p:style>
-          <a:lnRef idx="1">
-            <a:schemeClr val="accent1"/>
-          </a:lnRef>
-          <a:fillRef idx="3">
-            <a:schemeClr val="accent1"/>
-          </a:fillRef>
-          <a:effectRef idx="2">
-            <a:schemeClr val="accent1"/>
-          </a:effectRef>
-          <a:fontRef idx="minor">
-            <a:schemeClr val="lt1"/>
-          </a:fontRef>
-        </p:style>
-        <p:txBody>
-          <a:bodyPr rtlCol="0" anchor="ctr"/>
-          <a:lstStyle/>
-          <a:p>
-            <a:pPr algn="ctr"/>
-          </a:p>
-        </p:txBody>
-      </p:sp>
-      <p:sp>
-        <p:nvSpPr>
-          <p:cNvPr id="9" name="TextBox 8"/>
-          <p:cNvSpPr txBox="1"/>
-          <p:nvPr/>
-        </p:nvSpPr>
-        <p:spPr>
-          <a:xfrm>
-            <a:off x="685800" y="6583680"/>
-            <a:ext cx="6490411" cy="256032"/>
-          </a:xfrm>
-          <a:prstGeom prst="rect">
-            <a:avLst/>
-          </a:prstGeom>
-          <a:noFill/>
-        </p:spPr>
-        <p:txBody>
-          <a:bodyPr wrap="none">
-            <a:spAutoFit/>
-          </a:bodyPr>
-          <a:lstStyle/>
-          <a:p>
-            <a:pPr algn="l"/>
-            <a:r>
-              <a:rPr sz="700">
-                <a:solidFill>
-                  <a:srgbClr val="A0B4D2"/>
-                </a:solidFill>
-                <a:latin typeface="Consolas"/>
-              </a:rPr>
-              <a:t>FKB Campus  ·  M13</a:t>
-            </a:r>
-          </a:p>
-        </p:txBody>
-      </p:sp>
-      <p:sp>
-        <p:nvSpPr>
-          <p:cNvPr id="10" name="TextBox 9"/>
-          <p:cNvSpPr txBox="1"/>
-          <p:nvPr/>
-        </p:nvSpPr>
-        <p:spPr>
-          <a:xfrm>
-            <a:off x="7176211" y="6583680"/>
-            <a:ext cx="4326940" cy="256032"/>
-          </a:xfrm>
-          <a:prstGeom prst="rect">
-            <a:avLst/>
-          </a:prstGeom>
-          <a:noFill/>
-        </p:spPr>
-        <p:txBody>
-          <a:bodyPr wrap="none">
-            <a:spAutoFit/>
-          </a:bodyPr>
-          <a:lstStyle/>
-          <a:p>
-            <a:pPr algn="r"/>
-            <a:r>
-              <a:rPr sz="700">
-                <a:solidFill>
-                  <a:srgbClr val="A0B4D2"/>
-                </a:solidFill>
-                <a:latin typeface="Consolas"/>
-              </a:rPr>
-              <a:t>Übersicht</a:t>
             </a:r>
           </a:p>
         </p:txBody>
@@ -10398,7 +8552,7 @@
                 </a:solidFill>
                 <a:latin typeface="Arial"/>
               </a:rPr>
-              <a:t>Definition</a:t>
+              <a:t>Cross-Selling beginnt beim Bedarf, nicht bei der Produktliste</a:t>
             </a:r>
           </a:p>
         </p:txBody>
@@ -10440,7 +8594,45 @@
                 </a:solidFill>
                 <a:latin typeface="Arial"/>
               </a:rPr>
-              <a:t>→  Cross-Selling ist kein Verkaufsakt. Es ist das konsequente Ausfüllen eines Bedarfs, den der Kunde ohnehin hat – bei der eigenen Bank oder einem Wettbewerber.</a:t>
+              <a:t>→  Cross-Selling beginnt beim Bedarf des Kunden, nicht bei der Produktliste der Bank.</a:t>
+            </a:r>
+          </a:p>
+          <a:p>
+            <a:pPr marL="190500" indent="-190500">
+              <a:spcBef>
+                <a:spcPts val="400"/>
+              </a:spcBef>
+              <a:spcAft>
+                <a:spcPts val="200"/>
+              </a:spcAft>
+            </a:pPr>
+            <a:r>
+              <a:rPr sz="1300">
+                <a:solidFill>
+                  <a:srgbClr val="3D5466"/>
+                </a:solidFill>
+                <a:latin typeface="Arial"/>
+              </a:rPr>
+              <a:t>▸  Bedarfsorientiertes Cross-Selling (Pull) bindet und bringt Ertrag.</a:t>
+            </a:r>
+          </a:p>
+          <a:p>
+            <a:pPr marL="190500" indent="-190500">
+              <a:spcBef>
+                <a:spcPts val="400"/>
+              </a:spcBef>
+              <a:spcAft>
+                <a:spcPts val="200"/>
+              </a:spcAft>
+            </a:pPr>
+            <a:r>
+              <a:rPr sz="1300">
+                <a:solidFill>
+                  <a:srgbClr val="3D5466"/>
+                </a:solidFill>
+                <a:latin typeface="Arial"/>
+              </a:rPr>
+              <a:t>▸  Produkte drücken (Push) verbrennt Vertrauen – der Unterschied entscheidet über die Beziehung.</a:t>
             </a:r>
           </a:p>
         </p:txBody>
@@ -10778,7 +8970,7 @@
                 </a:solidFill>
                 <a:latin typeface="Arial"/>
               </a:rPr>
-              <a:t>Zwei Typen: Push vs. Pull</a:t>
+              <a:t>Push oder Pull: der entscheidende Unterschied</a:t>
             </a:r>
           </a:p>
         </p:txBody>
@@ -10804,6 +8996,25 @@
             <a:spAutoFit/>
           </a:bodyPr>
           <a:lstStyle/>
+          <a:p>
+            <a:pPr marL="177800" indent="-177800">
+              <a:spcBef>
+                <a:spcPts val="600"/>
+              </a:spcBef>
+              <a:spcAft>
+                <a:spcPts val="200"/>
+              </a:spcAft>
+            </a:pPr>
+            <a:r>
+              <a:rPr sz="1200" i="1">
+                <a:solidFill>
+                  <a:srgbClr val="3D5466"/>
+                </a:solidFill>
+                <a:latin typeface="Arial"/>
+              </a:rPr>
+              <a:t>→  Push fragt „Was können wir noch verkaufen?", Pull fragt „Welchen Bedarf hat der Kunde, den wir noch nicht decken?".</a:t>
+            </a:r>
+          </a:p>
           <a:p>
             <a:pPr marL="190500" indent="-190500">
               <a:spcBef>
@@ -10820,7 +9031,26 @@
                 </a:solidFill>
                 <a:latin typeface="Arial"/>
               </a:rPr>
-              <a:t>▸  ## 4.2 Wallet-Share-Analyse: Wo liegt das Potenzial?</a:t>
+              <a:t>▸  Push: von der Produktliste getrieben, kurzfristig, beziehungsschädlich.</a:t>
+            </a:r>
+          </a:p>
+          <a:p>
+            <a:pPr marL="190500" indent="-190500">
+              <a:spcBef>
+                <a:spcPts val="400"/>
+              </a:spcBef>
+              <a:spcAft>
+                <a:spcPts val="200"/>
+              </a:spcAft>
+            </a:pPr>
+            <a:r>
+              <a:rPr sz="1300">
+                <a:solidFill>
+                  <a:srgbClr val="3D5466"/>
+                </a:solidFill>
+                <a:latin typeface="Arial"/>
+              </a:rPr>
+              <a:t>▸  Pull: vom Kundenbedarf getrieben, nachhaltig, vertrauensbildend.</a:t>
             </a:r>
           </a:p>
         </p:txBody>
@@ -10936,7 +9166,7 @@
             <a:avLst/>
           </a:prstGeom>
           <a:solidFill>
-            <a:srgbClr val="EDEDF3"/>
+            <a:srgbClr val="1F2C56"/>
           </a:solidFill>
           <a:ln>
             <a:noFill/>
@@ -10966,57 +9196,14 @@
       </p:sp>
       <p:sp>
         <p:nvSpPr>
-          <p:cNvPr id="3" name="Rectangle 2"/>
-          <p:cNvSpPr/>
-          <p:nvPr/>
-        </p:nvSpPr>
-        <p:spPr>
-          <a:xfrm>
-            <a:off x="0" y="0"/>
-            <a:ext cx="12188952" cy="50292"/>
-          </a:xfrm>
-          <a:prstGeom prst="rect">
-            <a:avLst/>
-          </a:prstGeom>
-          <a:solidFill>
-            <a:srgbClr val="1F2C56"/>
-          </a:solidFill>
-          <a:ln>
-            <a:noFill/>
-          </a:ln>
-        </p:spPr>
-        <p:style>
-          <a:lnRef idx="1">
-            <a:schemeClr val="accent1"/>
-          </a:lnRef>
-          <a:fillRef idx="3">
-            <a:schemeClr val="accent1"/>
-          </a:fillRef>
-          <a:effectRef idx="2">
-            <a:schemeClr val="accent1"/>
-          </a:effectRef>
-          <a:fontRef idx="minor">
-            <a:schemeClr val="lt1"/>
-          </a:fontRef>
-        </p:style>
-        <p:txBody>
-          <a:bodyPr rtlCol="0" anchor="ctr"/>
-          <a:lstStyle/>
-          <a:p>
-            <a:pPr algn="ctr"/>
-          </a:p>
-        </p:txBody>
-      </p:sp>
-      <p:sp>
-        <p:nvSpPr>
-          <p:cNvPr id="4" name="TextBox 3"/>
+          <p:cNvPr id="3" name="TextBox 2"/>
           <p:cNvSpPr txBox="1"/>
           <p:nvPr/>
         </p:nvSpPr>
         <p:spPr>
           <a:xfrm>
-            <a:off x="685800" y="109728"/>
-            <a:ext cx="10817352" cy="228600"/>
+            <a:off x="685800" y="2377440"/>
+            <a:ext cx="10817352" cy="365760"/>
           </a:xfrm>
           <a:prstGeom prst="rect">
             <a:avLst/>
@@ -11031,70 +9218,27 @@
           <a:p>
             <a:pPr algn="l"/>
             <a:r>
-              <a:rPr sz="750">
-                <a:solidFill>
-                  <a:srgbClr val="78808C"/>
+              <a:rPr sz="1200">
+                <a:solidFill>
+                  <a:srgbClr val="D9C089"/>
                 </a:solidFill>
                 <a:latin typeface="Consolas"/>
               </a:rPr>
-              <a:t>M13  ·  INHALT</a:t>
-            </a:r>
-          </a:p>
-        </p:txBody>
-      </p:sp>
-      <p:sp>
-        <p:nvSpPr>
-          <p:cNvPr id="5" name="Rectangle 4"/>
+              <a:t>ANALYSE</a:t>
+            </a:r>
+          </a:p>
+        </p:txBody>
+      </p:sp>
+      <p:sp>
+        <p:nvSpPr>
+          <p:cNvPr id="4" name="Rectangle 3"/>
           <p:cNvSpPr/>
           <p:nvPr/>
         </p:nvSpPr>
         <p:spPr>
           <a:xfrm>
-            <a:off x="0" y="1234440"/>
-            <a:ext cx="12188952" cy="12700"/>
-          </a:xfrm>
-          <a:prstGeom prst="rect">
-            <a:avLst/>
-          </a:prstGeom>
-          <a:solidFill>
-            <a:srgbClr val="D8DFE4"/>
-          </a:solidFill>
-          <a:ln>
-            <a:noFill/>
-          </a:ln>
-        </p:spPr>
-        <p:style>
-          <a:lnRef idx="1">
-            <a:schemeClr val="accent1"/>
-          </a:lnRef>
-          <a:fillRef idx="3">
-            <a:schemeClr val="accent1"/>
-          </a:fillRef>
-          <a:effectRef idx="2">
-            <a:schemeClr val="accent1"/>
-          </a:effectRef>
-          <a:fontRef idx="minor">
-            <a:schemeClr val="lt1"/>
-          </a:fontRef>
-        </p:style>
-        <p:txBody>
-          <a:bodyPr rtlCol="0" anchor="ctr"/>
-          <a:lstStyle/>
-          <a:p>
-            <a:pPr algn="ctr"/>
-          </a:p>
-        </p:txBody>
-      </p:sp>
-      <p:sp>
-        <p:nvSpPr>
-          <p:cNvPr id="6" name="Rectangle 5"/>
-          <p:cNvSpPr/>
-          <p:nvPr/>
-        </p:nvSpPr>
-        <p:spPr>
-          <a:xfrm>
-            <a:off x="685800" y="502920"/>
-            <a:ext cx="36576" cy="658368"/>
+            <a:off x="685800" y="2788920"/>
+            <a:ext cx="548640" cy="38100"/>
           </a:xfrm>
           <a:prstGeom prst="rect">
             <a:avLst/>
@@ -11130,14 +9274,14 @@
       </p:sp>
       <p:sp>
         <p:nvSpPr>
-          <p:cNvPr id="7" name="TextBox 6"/>
+          <p:cNvPr id="5" name="TextBox 4"/>
           <p:cNvSpPr txBox="1"/>
           <p:nvPr/>
         </p:nvSpPr>
         <p:spPr>
           <a:xfrm>
-            <a:off x="813816" y="502920"/>
-            <a:ext cx="10634472" cy="685800"/>
+            <a:off x="685800" y="3017520"/>
+            <a:ext cx="10817352" cy="1463040"/>
           </a:xfrm>
           <a:prstGeom prst="rect">
             <a:avLst/>
@@ -11152,27 +9296,27 @@
           <a:p>
             <a:pPr algn="l"/>
             <a:r>
-              <a:rPr sz="2400" b="1" i="0">
-                <a:solidFill>
-                  <a:srgbClr val="1F2C56"/>
+              <a:rPr sz="4000" b="1" i="0">
+                <a:solidFill>
+                  <a:srgbClr val="FFFFFF"/>
                 </a:solidFill>
                 <a:latin typeface="Arial"/>
               </a:rPr>
-              <a:t>Das Konzept</a:t>
-            </a:r>
-          </a:p>
-        </p:txBody>
-      </p:sp>
-      <p:sp>
-        <p:nvSpPr>
-          <p:cNvPr id="8" name="TextBox 7"/>
+              <a:t>Wallet-Share &amp; Anlässe</a:t>
+            </a:r>
+          </a:p>
+        </p:txBody>
+      </p:sp>
+      <p:sp>
+        <p:nvSpPr>
+          <p:cNvPr id="6" name="TextBox 5"/>
           <p:cNvSpPr txBox="1"/>
           <p:nvPr/>
         </p:nvSpPr>
         <p:spPr>
           <a:xfrm>
-            <a:off x="685800" y="1417320"/>
-            <a:ext cx="10817352" cy="4892040"/>
+            <a:off x="685800" y="4480560"/>
+            <a:ext cx="8653881" cy="1280160"/>
           </a:xfrm>
           <a:prstGeom prst="rect">
             <a:avLst/>
@@ -11180,84 +9324,34 @@
           <a:noFill/>
         </p:spPr>
         <p:txBody>
-          <a:bodyPr wrap="square" anchor="ctr">
+          <a:bodyPr wrap="square">
             <a:spAutoFit/>
           </a:bodyPr>
           <a:lstStyle/>
           <a:p>
-            <a:pPr marL="190500" indent="-190500">
-              <a:spcBef>
-                <a:spcPts val="400"/>
-              </a:spcBef>
-              <a:spcAft>
-                <a:spcPts val="200"/>
-              </a:spcAft>
-            </a:pPr>
-            <a:r>
-              <a:rPr sz="1300">
-                <a:solidFill>
-                  <a:srgbClr val="3D5466"/>
+            <a:pPr algn="l"/>
+            <a:r>
+              <a:rPr sz="1600" b="0" i="0">
+                <a:solidFill>
+                  <a:srgbClr val="C8D2E6"/>
                 </a:solidFill>
                 <a:latin typeface="Arial"/>
               </a:rPr>
-              <a:t>▸  Das unausgeschöpfte Potenzial von 60 % ist nicht verloren – es ist bei einem Wettbewerber.</a:t>
-            </a:r>
-          </a:p>
-        </p:txBody>
-      </p:sp>
-      <p:sp>
-        <p:nvSpPr>
-          <p:cNvPr id="9" name="Rectangle 8"/>
-          <p:cNvSpPr/>
-          <p:nvPr/>
-        </p:nvSpPr>
-        <p:spPr>
-          <a:xfrm>
-            <a:off x="0" y="6510528"/>
-            <a:ext cx="12188952" cy="347472"/>
-          </a:xfrm>
-          <a:prstGeom prst="rect">
-            <a:avLst/>
-          </a:prstGeom>
-          <a:solidFill>
-            <a:srgbClr val="0A1937"/>
-          </a:solidFill>
-          <a:ln>
-            <a:noFill/>
-          </a:ln>
-        </p:spPr>
-        <p:style>
-          <a:lnRef idx="1">
-            <a:schemeClr val="accent1"/>
-          </a:lnRef>
-          <a:fillRef idx="3">
-            <a:schemeClr val="accent1"/>
-          </a:fillRef>
-          <a:effectRef idx="2">
-            <a:schemeClr val="accent1"/>
-          </a:effectRef>
-          <a:fontRef idx="minor">
-            <a:schemeClr val="lt1"/>
-          </a:fontRef>
-        </p:style>
-        <p:txBody>
-          <a:bodyPr rtlCol="0" anchor="ctr"/>
-          <a:lstStyle/>
-          <a:p>
-            <a:pPr algn="ctr"/>
-          </a:p>
-        </p:txBody>
-      </p:sp>
-      <p:sp>
-        <p:nvSpPr>
-          <p:cNvPr id="10" name="TextBox 9"/>
+              <a:t>Das ungenutzte Potenzial im Bestand sichtbar machen.</a:t>
+            </a:r>
+          </a:p>
+        </p:txBody>
+      </p:sp>
+      <p:sp>
+        <p:nvSpPr>
+          <p:cNvPr id="7" name="TextBox 6"/>
           <p:cNvSpPr txBox="1"/>
           <p:nvPr/>
         </p:nvSpPr>
         <p:spPr>
           <a:xfrm>
-            <a:off x="685800" y="6583680"/>
-            <a:ext cx="6490411" cy="256032"/>
+            <a:off x="685800" y="6355080"/>
+            <a:ext cx="10817352" cy="274320"/>
           </a:xfrm>
           <a:prstGeom prst="rect">
             <a:avLst/>
@@ -11274,7 +9368,7 @@
             <a:r>
               <a:rPr sz="700">
                 <a:solidFill>
-                  <a:srgbClr val="A0B4D2"/>
+                  <a:srgbClr val="8CA0C3"/>
                 </a:solidFill>
                 <a:latin typeface="Consolas"/>
               </a:rPr>
@@ -11538,7 +9632,7 @@
                 </a:solidFill>
                 <a:latin typeface="Arial"/>
               </a:rPr>
-              <a:t>Potenzialanalyse in agree</a:t>
+              <a:t>Wallet-Share: wo das Potenzial liegt</a:t>
             </a:r>
           </a:p>
         </p:txBody>
@@ -11564,6 +9658,25 @@
             <a:spAutoFit/>
           </a:bodyPr>
           <a:lstStyle/>
+          <a:p>
+            <a:pPr marL="177800" indent="-177800">
+              <a:spcBef>
+                <a:spcPts val="600"/>
+              </a:spcBef>
+              <a:spcAft>
+                <a:spcPts val="200"/>
+              </a:spcAft>
+            </a:pPr>
+            <a:r>
+              <a:rPr sz="1200" i="1">
+                <a:solidFill>
+                  <a:srgbClr val="3D5466"/>
+                </a:solidFill>
+                <a:latin typeface="Arial"/>
+              </a:rPr>
+              <a:t>→  Der Wallet-Share zeigt, welchen Anteil am Finanzbedarf des Kunden wir schon halten – und wo der Verbund fehlt.</a:t>
+            </a:r>
+          </a:p>
           <a:p>
             <a:pPr marL="190500" indent="-190500">
               <a:spcBef>
@@ -11580,7 +9693,7 @@
                 </a:solidFill>
                 <a:latin typeface="Arial"/>
               </a:rPr>
-              <a:t>▸  agree bietet über das CRM-Modul und den UnternehmerDialog strukturierte Hilfsmittel zur Potenzialanalyse. Berater sollten vor jedem Jahresgespräch folgende Felder prüfen:</a:t>
+              <a:t>▸  Potenzialanalyse in agree: bestehende Produkte gegen den typischen Bedarf der Branche halten.</a:t>
             </a:r>
           </a:p>
           <a:p>
@@ -11599,7 +9712,7 @@
                 </a:solidFill>
                 <a:latin typeface="Arial"/>
               </a:rPr>
-              <a:t>▸  Empfehlung: Erstellen Sie für Ihre Top-20-Kunden eine einfache Wallet-Share-Schätzung anhand dieser fünf Dimensionen, bevor Sie das Jahresgespräch vorbereiten.</a:t>
+              <a:t>▸  Ereignisbasierte Anlässe (Investition, Nachfolge, Auslandsgeschäft) öffnen den Cross-Selling-Bedarf.</a:t>
             </a:r>
           </a:p>
         </p:txBody>
@@ -11715,7 +9828,7 @@
             <a:avLst/>
           </a:prstGeom>
           <a:solidFill>
-            <a:srgbClr val="EDEDF3"/>
+            <a:srgbClr val="1F2C56"/>
           </a:solidFill>
           <a:ln>
             <a:noFill/>
@@ -11745,57 +9858,14 @@
       </p:sp>
       <p:sp>
         <p:nvSpPr>
-          <p:cNvPr id="3" name="Rectangle 2"/>
-          <p:cNvSpPr/>
-          <p:nvPr/>
-        </p:nvSpPr>
-        <p:spPr>
-          <a:xfrm>
-            <a:off x="0" y="0"/>
-            <a:ext cx="12188952" cy="50292"/>
-          </a:xfrm>
-          <a:prstGeom prst="rect">
-            <a:avLst/>
-          </a:prstGeom>
-          <a:solidFill>
-            <a:srgbClr val="1F2C56"/>
-          </a:solidFill>
-          <a:ln>
-            <a:noFill/>
-          </a:ln>
-        </p:spPr>
-        <p:style>
-          <a:lnRef idx="1">
-            <a:schemeClr val="accent1"/>
-          </a:lnRef>
-          <a:fillRef idx="3">
-            <a:schemeClr val="accent1"/>
-          </a:fillRef>
-          <a:effectRef idx="2">
-            <a:schemeClr val="accent1"/>
-          </a:effectRef>
-          <a:fontRef idx="minor">
-            <a:schemeClr val="lt1"/>
-          </a:fontRef>
-        </p:style>
-        <p:txBody>
-          <a:bodyPr rtlCol="0" anchor="ctr"/>
-          <a:lstStyle/>
-          <a:p>
-            <a:pPr algn="ctr"/>
-          </a:p>
-        </p:txBody>
-      </p:sp>
-      <p:sp>
-        <p:nvSpPr>
-          <p:cNvPr id="4" name="TextBox 3"/>
+          <p:cNvPr id="3" name="TextBox 2"/>
           <p:cNvSpPr txBox="1"/>
           <p:nvPr/>
         </p:nvSpPr>
         <p:spPr>
           <a:xfrm>
-            <a:off x="685800" y="109728"/>
-            <a:ext cx="10817352" cy="228600"/>
+            <a:off x="685800" y="2377440"/>
+            <a:ext cx="10817352" cy="365760"/>
           </a:xfrm>
           <a:prstGeom prst="rect">
             <a:avLst/>
@@ -11810,70 +9880,27 @@
           <a:p>
             <a:pPr algn="l"/>
             <a:r>
-              <a:rPr sz="750">
-                <a:solidFill>
-                  <a:srgbClr val="78808C"/>
+              <a:rPr sz="1200">
+                <a:solidFill>
+                  <a:srgbClr val="D9C089"/>
                 </a:solidFill>
                 <a:latin typeface="Consolas"/>
               </a:rPr>
-              <a:t>M13  ·  INHALT</a:t>
-            </a:r>
-          </a:p>
-        </p:txBody>
-      </p:sp>
-      <p:sp>
-        <p:nvSpPr>
-          <p:cNvPr id="5" name="Rectangle 4"/>
+              <a:t>SYSTEMATIK</a:t>
+            </a:r>
+          </a:p>
+        </p:txBody>
+      </p:sp>
+      <p:sp>
+        <p:nvSpPr>
+          <p:cNvPr id="4" name="Rectangle 3"/>
           <p:cNvSpPr/>
           <p:nvPr/>
         </p:nvSpPr>
         <p:spPr>
           <a:xfrm>
-            <a:off x="0" y="1234440"/>
-            <a:ext cx="12188952" cy="12700"/>
-          </a:xfrm>
-          <a:prstGeom prst="rect">
-            <a:avLst/>
-          </a:prstGeom>
-          <a:solidFill>
-            <a:srgbClr val="D8DFE4"/>
-          </a:solidFill>
-          <a:ln>
-            <a:noFill/>
-          </a:ln>
-        </p:spPr>
-        <p:style>
-          <a:lnRef idx="1">
-            <a:schemeClr val="accent1"/>
-          </a:lnRef>
-          <a:fillRef idx="3">
-            <a:schemeClr val="accent1"/>
-          </a:fillRef>
-          <a:effectRef idx="2">
-            <a:schemeClr val="accent1"/>
-          </a:effectRef>
-          <a:fontRef idx="minor">
-            <a:schemeClr val="lt1"/>
-          </a:fontRef>
-        </p:style>
-        <p:txBody>
-          <a:bodyPr rtlCol="0" anchor="ctr"/>
-          <a:lstStyle/>
-          <a:p>
-            <a:pPr algn="ctr"/>
-          </a:p>
-        </p:txBody>
-      </p:sp>
-      <p:sp>
-        <p:nvSpPr>
-          <p:cNvPr id="6" name="Rectangle 5"/>
-          <p:cNvSpPr/>
-          <p:nvPr/>
-        </p:nvSpPr>
-        <p:spPr>
-          <a:xfrm>
-            <a:off x="685800" y="502920"/>
-            <a:ext cx="36576" cy="658368"/>
+            <a:off x="685800" y="2788920"/>
+            <a:ext cx="548640" cy="38100"/>
           </a:xfrm>
           <a:prstGeom prst="rect">
             <a:avLst/>
@@ -11909,14 +9936,14 @@
       </p:sp>
       <p:sp>
         <p:nvSpPr>
-          <p:cNvPr id="7" name="TextBox 6"/>
+          <p:cNvPr id="5" name="TextBox 4"/>
           <p:cNvSpPr txBox="1"/>
           <p:nvPr/>
         </p:nvSpPr>
         <p:spPr>
           <a:xfrm>
-            <a:off x="813816" y="502920"/>
-            <a:ext cx="10634472" cy="685800"/>
+            <a:off x="685800" y="3017520"/>
+            <a:ext cx="10817352" cy="1463040"/>
           </a:xfrm>
           <a:prstGeom prst="rect">
             <a:avLst/>
@@ -11931,27 +9958,27 @@
           <a:p>
             <a:pPr algn="l"/>
             <a:r>
-              <a:rPr sz="2400" b="1" i="0">
-                <a:solidFill>
-                  <a:srgbClr val="1F2C56"/>
+              <a:rPr sz="4000" b="1" i="0">
+                <a:solidFill>
+                  <a:srgbClr val="FFFFFF"/>
                 </a:solidFill>
                 <a:latin typeface="Arial"/>
               </a:rPr>
-              <a:t>Ereignisbasierte Cross-Selling-Anlässe</a:t>
-            </a:r>
-          </a:p>
-        </p:txBody>
-      </p:sp>
-      <p:sp>
-        <p:nvSpPr>
-          <p:cNvPr id="8" name="TextBox 7"/>
+              <a:t>Der 4-Schritte-Prozess</a:t>
+            </a:r>
+          </a:p>
+        </p:txBody>
+      </p:sp>
+      <p:sp>
+        <p:nvSpPr>
+          <p:cNvPr id="6" name="TextBox 5"/>
           <p:cNvSpPr txBox="1"/>
           <p:nvPr/>
         </p:nvSpPr>
         <p:spPr>
           <a:xfrm>
-            <a:off x="685800" y="1417320"/>
-            <a:ext cx="10817352" cy="4892040"/>
+            <a:off x="685800" y="4480560"/>
+            <a:ext cx="8653881" cy="1280160"/>
           </a:xfrm>
           <a:prstGeom prst="rect">
             <a:avLst/>
@@ -11959,122 +9986,34 @@
           <a:noFill/>
         </p:spPr>
         <p:txBody>
-          <a:bodyPr wrap="square" anchor="ctr">
+          <a:bodyPr wrap="square">
             <a:spAutoFit/>
           </a:bodyPr>
           <a:lstStyle/>
           <a:p>
-            <a:pPr marL="190500" indent="-190500">
-              <a:spcBef>
-                <a:spcPts val="400"/>
-              </a:spcBef>
-              <a:spcAft>
-                <a:spcPts val="200"/>
-              </a:spcAft>
-            </a:pPr>
-            <a:r>
-              <a:rPr sz="1300">
-                <a:solidFill>
-                  <a:srgbClr val="3D5466"/>
+            <a:pPr algn="l"/>
+            <a:r>
+              <a:rPr sz="1600" b="0" i="0">
+                <a:solidFill>
+                  <a:srgbClr val="C8D2E6"/>
                 </a:solidFill>
                 <a:latin typeface="Arial"/>
               </a:rPr>
-              <a:t>▸  Das Jahresgespräch ist nur einer von vielen Anlässen. In der Praxis öffnen oft Ereignisse das Gespräch besser als der Jahreskalender – weil der Bedarf dann für den Kunden selbst spürbar ist:</a:t>
-            </a:r>
-          </a:p>
-          <a:p>
-            <a:pPr marL="190500" indent="-190500">
-              <a:spcBef>
-                <a:spcPts val="400"/>
-              </a:spcBef>
-              <a:spcAft>
-                <a:spcPts val="200"/>
-              </a:spcAft>
-            </a:pPr>
-            <a:r>
-              <a:rPr sz="1300">
-                <a:solidFill>
-                  <a:srgbClr val="3D5466"/>
-                </a:solidFill>
-                <a:latin typeface="Arial"/>
-              </a:rPr>
-              <a:t>▸  ## 4.3 Der 4-Schritte-Cross-Selling-Prozess</a:t>
-            </a:r>
-          </a:p>
-          <a:p>
-            <a:pPr marL="190500" indent="-190500">
-              <a:spcBef>
-                <a:spcPts val="400"/>
-              </a:spcBef>
-              <a:spcAft>
-                <a:spcPts val="200"/>
-              </a:spcAft>
-            </a:pPr>
-            <a:r>
-              <a:rPr sz="1300">
-                <a:solidFill>
-                  <a:srgbClr val="3D5466"/>
-                </a:solidFill>
-                <a:latin typeface="Arial"/>
-              </a:rPr>
-              <a:t>▸  Systematisches Cross-Selling folgt einem klaren Prozess – nicht dem Zufall eines Gesprächsmoments.</a:t>
-            </a:r>
-          </a:p>
-        </p:txBody>
-      </p:sp>
-      <p:sp>
-        <p:nvSpPr>
-          <p:cNvPr id="9" name="Rectangle 8"/>
-          <p:cNvSpPr/>
-          <p:nvPr/>
-        </p:nvSpPr>
-        <p:spPr>
-          <a:xfrm>
-            <a:off x="0" y="6510528"/>
-            <a:ext cx="12188952" cy="347472"/>
-          </a:xfrm>
-          <a:prstGeom prst="rect">
-            <a:avLst/>
-          </a:prstGeom>
-          <a:solidFill>
-            <a:srgbClr val="0A1937"/>
-          </a:solidFill>
-          <a:ln>
-            <a:noFill/>
-          </a:ln>
-        </p:spPr>
-        <p:style>
-          <a:lnRef idx="1">
-            <a:schemeClr val="accent1"/>
-          </a:lnRef>
-          <a:fillRef idx="3">
-            <a:schemeClr val="accent1"/>
-          </a:fillRef>
-          <a:effectRef idx="2">
-            <a:schemeClr val="accent1"/>
-          </a:effectRef>
-          <a:fontRef idx="minor">
-            <a:schemeClr val="lt1"/>
-          </a:fontRef>
-        </p:style>
-        <p:txBody>
-          <a:bodyPr rtlCol="0" anchor="ctr"/>
-          <a:lstStyle/>
-          <a:p>
-            <a:pPr algn="ctr"/>
-          </a:p>
-        </p:txBody>
-      </p:sp>
-      <p:sp>
-        <p:nvSpPr>
-          <p:cNvPr id="10" name="TextBox 9"/>
+              <a:t>Von der Analyse über die Hypothese zum dokumentierten Gespräch.</a:t>
+            </a:r>
+          </a:p>
+        </p:txBody>
+      </p:sp>
+      <p:sp>
+        <p:nvSpPr>
+          <p:cNvPr id="7" name="TextBox 6"/>
           <p:cNvSpPr txBox="1"/>
           <p:nvPr/>
         </p:nvSpPr>
         <p:spPr>
           <a:xfrm>
-            <a:off x="685800" y="6583680"/>
-            <a:ext cx="6490411" cy="256032"/>
+            <a:off x="685800" y="6355080"/>
+            <a:ext cx="10817352" cy="274320"/>
           </a:xfrm>
           <a:prstGeom prst="rect">
             <a:avLst/>
@@ -12091,7 +10030,7 @@
             <a:r>
               <a:rPr sz="700">
                 <a:solidFill>
-                  <a:srgbClr val="A0B4D2"/>
+                  <a:srgbClr val="8CA0C3"/>
                 </a:solidFill>
                 <a:latin typeface="Consolas"/>
               </a:rPr>

</xml_diff>